<commit_message>
Extend retail KPIs and row lineage
Co-authored-by: Copilot <223556219+Copilot@users.noreply.github.com>
</commit_message>
<xml_diff>
--- a/presentation/retail_ceo_debrief.pptx
+++ b/presentation/retail_ceo_debrief.pptx
@@ -14,9 +14,12 @@
     <p:sldId id="262" r:id="rId8"/>
     <p:sldId id="263" r:id="rId9"/>
     <p:sldId id="264" r:id="rId10"/>
+    <p:sldId id="265" r:id="rId11"/>
+    <p:sldId id="266" r:id="rId12"/>
+    <p:sldId id="267" r:id="rId13"/>
   </p:sldIdLst>
   <p:notesMasterIdLst>
-    <p:notesMasterId r:id="rId11"/>
+    <p:notesMasterId r:id="rId14"/>
   </p:notesMasterIdLst>
   <p:sldSz cx="12192000" cy="6858000"/>
   <p:notesSz cx="6858000" cy="12192000"/>
@@ -534,6 +537,270 @@
             <a:fld id="{F7021451-1387-4CA6-816F-3879F97B5CBC}" type="slidenum">
               <a:rPr lang="en-US"/>
               <a:t>1</a:t>
+            </a:fld>
+            <a:endParaRPr lang="en-US"/>
+          </a:p>
+        </p:txBody>
+      </p:sp>
+    </p:spTree>
+    <p:extLst>
+      <p:ext uri="{BB962C8B-B14F-4D97-AF65-F5344CB8AC3E}">
+        <p14:creationId xmlns:p14="http://schemas.microsoft.com/office/powerpoint/2010/main" val="1024086991"/>
+      </p:ext>
+    </p:extLst>
+  </p:cSld>
+  <p:clrMapOvr>
+    <a:masterClrMapping/>
+  </p:clrMapOvr>
+</p:notes>
+</file>
+
+<file path=ppt/notesSlides/notesSlide10.xml><?xml version="1.0" encoding="utf-8"?>
+<p:notes xmlns:a="http://schemas.openxmlformats.org/drawingml/2006/main" xmlns:r="http://schemas.openxmlformats.org/officeDocument/2006/relationships" xmlns:p="http://schemas.openxmlformats.org/presentationml/2006/main">
+  <p:cSld>
+    <p:spTree>
+      <p:nvGrpSpPr>
+        <p:cNvPr id="1" name=""/>
+        <p:cNvGrpSpPr/>
+        <p:nvPr/>
+      </p:nvGrpSpPr>
+      <p:grpSpPr>
+        <a:xfrm>
+          <a:off x="0" y="0"/>
+          <a:ext cx="0" cy="0"/>
+          <a:chOff x="0" y="0"/>
+          <a:chExt cx="0" cy="0"/>
+        </a:xfrm>
+      </p:grpSpPr>
+      <p:sp>
+        <p:nvSpPr>
+          <p:cNvPr id="2" name="Slide Image Placeholder 1"/>
+          <p:cNvSpPr>
+            <a:spLocks noGrp="1" noRot="1" noChangeAspect="1"/>
+          </p:cNvSpPr>
+          <p:nvPr>
+            <p:ph type="sldImg"/>
+          </p:nvPr>
+        </p:nvSpPr>
+        <p:spPr/>
+      </p:sp>
+      <p:sp>
+        <p:nvSpPr>
+          <p:cNvPr id="3" name="Notes Placeholder 2"/>
+          <p:cNvSpPr>
+            <a:spLocks noGrp="1"/>
+          </p:cNvSpPr>
+          <p:nvPr>
+            <p:ph type="body" idx="1"/>
+          </p:nvPr>
+        </p:nvSpPr>
+        <p:spPr/>
+        <p:txBody>
+          <a:bodyPr/>
+          <a:lstStyle/>
+          <a:p>
+            <a:r>
+              <a:rPr lang="en-US" dirty="0"/>
+              <a:t>The CSV has 509,480 rows and 499,665 distinct transaction IDs, leaving 9,815 excess versions. The version audit keeps all 509,480 rows; one latest version per ID feeds the 499,665-row fact and 9,815 older versions are explicitly marked for triage. The duplicate issue category contains both versions for each collided ID (19,630 rows). Other issue categories overlap, so their counts must not be summed as distinct dropped records.</a:t>
+            </a:r>
+            <a:endParaRPr lang="en-US" dirty="0"/>
+          </a:p>
+        </p:txBody>
+      </p:sp>
+      <p:sp>
+        <p:nvSpPr>
+          <p:cNvPr id="4" name="Slide Number Placeholder 3"/>
+          <p:cNvSpPr>
+            <a:spLocks noGrp="1"/>
+          </p:cNvSpPr>
+          <p:nvPr>
+            <p:ph type="sldNum" sz="quarter" idx="10"/>
+          </p:nvPr>
+        </p:nvSpPr>
+        <p:spPr/>
+        <p:txBody>
+          <a:bodyPr/>
+          <a:lstStyle/>
+          <a:p>
+            <a:fld id="{F7021451-1387-4CA6-816F-3879F97B5CBC}" type="slidenum">
+              <a:rPr lang="en-US"/>
+              <a:t>10</a:t>
+            </a:fld>
+            <a:endParaRPr lang="en-US"/>
+          </a:p>
+        </p:txBody>
+      </p:sp>
+    </p:spTree>
+    <p:extLst>
+      <p:ext uri="{BB962C8B-B14F-4D97-AF65-F5344CB8AC3E}">
+        <p14:creationId xmlns:p14="http://schemas.microsoft.com/office/powerpoint/2010/main" val="1024086991"/>
+      </p:ext>
+    </p:extLst>
+  </p:cSld>
+  <p:clrMapOvr>
+    <a:masterClrMapping/>
+  </p:clrMapOvr>
+</p:notes>
+</file>
+
+<file path=ppt/notesSlides/notesSlide11.xml><?xml version="1.0" encoding="utf-8"?>
+<p:notes xmlns:a="http://schemas.openxmlformats.org/drawingml/2006/main" xmlns:r="http://schemas.openxmlformats.org/officeDocument/2006/relationships" xmlns:p="http://schemas.openxmlformats.org/presentationml/2006/main">
+  <p:cSld>
+    <p:spTree>
+      <p:nvGrpSpPr>
+        <p:cNvPr id="1" name=""/>
+        <p:cNvGrpSpPr/>
+        <p:nvPr/>
+      </p:nvGrpSpPr>
+      <p:grpSpPr>
+        <a:xfrm>
+          <a:off x="0" y="0"/>
+          <a:ext cx="0" cy="0"/>
+          <a:chOff x="0" y="0"/>
+          <a:chExt cx="0" cy="0"/>
+        </a:xfrm>
+      </p:grpSpPr>
+      <p:sp>
+        <p:nvSpPr>
+          <p:cNvPr id="2" name="Slide Image Placeholder 1"/>
+          <p:cNvSpPr>
+            <a:spLocks noGrp="1" noRot="1" noChangeAspect="1"/>
+          </p:cNvSpPr>
+          <p:nvPr>
+            <p:ph type="sldImg"/>
+          </p:nvPr>
+        </p:nvSpPr>
+        <p:spPr/>
+      </p:sp>
+      <p:sp>
+        <p:nvSpPr>
+          <p:cNvPr id="3" name="Notes Placeholder 2"/>
+          <p:cNvSpPr>
+            <a:spLocks noGrp="1"/>
+          </p:cNvSpPr>
+          <p:nvPr>
+            <p:ph type="body" idx="1"/>
+          </p:nvPr>
+        </p:nvSpPr>
+        <p:spPr/>
+        <p:txBody>
+          <a:bodyPr/>
+          <a:lstStyle/>
+          <a:p>
+            <a:r>
+              <a:rPr lang="en-US" dirty="0"/>
+              <a:t>This is a 3-dimension, 1-event-fact star. The date dimension is a complete calendar, even though the extract has only one day-of-month. The reported row counts include the Unknown member for product and store. The project has aggregate marts for convenient reporting, not a second periodic-snapshot fact. Date filtering is recommended for a business report and enables time drilldowns; it is not a condition for a mathematically valid event-fact query.</a:t>
+            </a:r>
+            <a:endParaRPr lang="en-US" dirty="0"/>
+          </a:p>
+        </p:txBody>
+      </p:sp>
+      <p:sp>
+        <p:nvSpPr>
+          <p:cNvPr id="4" name="Slide Number Placeholder 3"/>
+          <p:cNvSpPr>
+            <a:spLocks noGrp="1"/>
+          </p:cNvSpPr>
+          <p:nvPr>
+            <p:ph type="sldNum" sz="quarter" idx="10"/>
+          </p:nvPr>
+        </p:nvSpPr>
+        <p:spPr/>
+        <p:txBody>
+          <a:bodyPr/>
+          <a:lstStyle/>
+          <a:p>
+            <a:fld id="{F7021451-1387-4CA6-816F-3879F97B5CBC}" type="slidenum">
+              <a:rPr lang="en-US"/>
+              <a:t>11</a:t>
+            </a:fld>
+            <a:endParaRPr lang="en-US"/>
+          </a:p>
+        </p:txBody>
+      </p:sp>
+    </p:spTree>
+    <p:extLst>
+      <p:ext uri="{BB962C8B-B14F-4D97-AF65-F5344CB8AC3E}">
+        <p14:creationId xmlns:p14="http://schemas.microsoft.com/office/powerpoint/2010/main" val="1024086991"/>
+      </p:ext>
+    </p:extLst>
+  </p:cSld>
+  <p:clrMapOvr>
+    <a:masterClrMapping/>
+  </p:clrMapOvr>
+</p:notes>
+</file>
+
+<file path=ppt/notesSlides/notesSlide12.xml><?xml version="1.0" encoding="utf-8"?>
+<p:notes xmlns:a="http://schemas.openxmlformats.org/drawingml/2006/main" xmlns:r="http://schemas.openxmlformats.org/officeDocument/2006/relationships" xmlns:p="http://schemas.openxmlformats.org/presentationml/2006/main">
+  <p:cSld>
+    <p:spTree>
+      <p:nvGrpSpPr>
+        <p:cNvPr id="1" name=""/>
+        <p:cNvGrpSpPr/>
+        <p:nvPr/>
+      </p:nvGrpSpPr>
+      <p:grpSpPr>
+        <a:xfrm>
+          <a:off x="0" y="0"/>
+          <a:ext cx="0" cy="0"/>
+          <a:chOff x="0" y="0"/>
+          <a:chExt cx="0" cy="0"/>
+        </a:xfrm>
+      </p:grpSpPr>
+      <p:sp>
+        <p:nvSpPr>
+          <p:cNvPr id="2" name="Slide Image Placeholder 1"/>
+          <p:cNvSpPr>
+            <a:spLocks noGrp="1" noRot="1" noChangeAspect="1"/>
+          </p:cNvSpPr>
+          <p:nvPr>
+            <p:ph type="sldImg"/>
+          </p:nvPr>
+        </p:nvSpPr>
+        <p:spPr/>
+      </p:sp>
+      <p:sp>
+        <p:nvSpPr>
+          <p:cNvPr id="3" name="Notes Placeholder 2"/>
+          <p:cNvSpPr>
+            <a:spLocks noGrp="1"/>
+          </p:cNvSpPr>
+          <p:nvPr>
+            <p:ph type="body" idx="1"/>
+          </p:nvPr>
+        </p:nvSpPr>
+        <p:spPr/>
+        <p:txBody>
+          <a:bodyPr/>
+          <a:lstStyle/>
+          <a:p>
+            <a:r>
+              <a:rPr lang="en-US" dirty="0"/>
+              <a:t>The 2022 weighted area productivity is $0.27 net sales, $0.16 standard cost of sales and $0.11 gross profit per reported square foot. The denominator is 47,432,126 sqft across stores with valid positive area. Store 200 has zero sqft and is flagged, not included in the area ratio; its sales are not removed from company sales. The different team tabs share global net sales and standard gross-profit formulas. Landed cost, unadjusted-versus-pack-adjusted standard cost, and monthly-versus-annual store cost remain explicitly labelled sensitivity views, not competing definitions or net profit.</a:t>
+            </a:r>
+            <a:endParaRPr lang="en-US" dirty="0"/>
+          </a:p>
+        </p:txBody>
+      </p:sp>
+      <p:sp>
+        <p:nvSpPr>
+          <p:cNvPr id="4" name="Slide Number Placeholder 3"/>
+          <p:cNvSpPr>
+            <a:spLocks noGrp="1"/>
+          </p:cNvSpPr>
+          <p:nvPr>
+            <p:ph type="sldNum" sz="quarter" idx="10"/>
+          </p:nvPr>
+        </p:nvSpPr>
+        <p:spPr/>
+        <p:txBody>
+          <a:bodyPr/>
+          <a:lstStyle/>
+          <a:p>
+            <a:fld id="{F7021451-1387-4CA6-816F-3879F97B5CBC}" type="slidenum">
+              <a:rPr lang="en-US"/>
+              <a:t>12</a:t>
             </a:fld>
             <a:endParaRPr lang="en-US"/>
           </a:p>
@@ -2483,6 +2750,3440 @@
             <a:fld id="{F7021451-1387-4CA6-816F-3879F97B5CBC}" type="slidenum">
               <a:rPr b="0" lang="en-US"/>
               <a:t>1</a:t>
+            </a:fld>
+            <a:endParaRPr lang="en-US"/>
+          </a:p>
+        </p:txBody>
+      </p:sp>
+    </p:spTree>
+  </p:cSld>
+  <p:clrMapOvr>
+    <a:masterClrMapping/>
+  </p:clrMapOvr>
+</p:sld>
+</file>
+
+<file path=ppt/slides/slide10.xml><?xml version="1.0" encoding="utf-8"?>
+<p:sld xmlns:a="http://schemas.openxmlformats.org/drawingml/2006/main" xmlns:r="http://schemas.openxmlformats.org/officeDocument/2006/relationships" xmlns:p="http://schemas.openxmlformats.org/presentationml/2006/main">
+  <p:cSld name="Slide 10">
+    <p:spTree>
+      <p:nvGrpSpPr>
+        <p:cNvPr id="1" name=""/>
+        <p:cNvGrpSpPr/>
+        <p:nvPr/>
+      </p:nvGrpSpPr>
+      <p:grpSpPr>
+        <a:xfrm>
+          <a:off x="0" y="0"/>
+          <a:ext cx="0" cy="0"/>
+          <a:chOff x="0" y="0"/>
+          <a:chExt cx="0" cy="0"/>
+        </a:xfrm>
+      </p:grpSpPr>
+      <p:sp>
+        <p:nvSpPr>
+          <p:cNvPr id="2" name="Text 0"/>
+          <p:cNvSpPr/>
+          <p:nvPr/>
+        </p:nvSpPr>
+        <p:spPr>
+          <a:xfrm>
+            <a:off x="566928" y="384048"/>
+            <a:ext cx="10789920" cy="219456"/>
+          </a:xfrm>
+          <a:prstGeom prst="rect">
+            <a:avLst/>
+          </a:prstGeom>
+          <a:noFill/>
+          <a:ln/>
+        </p:spPr>
+        <p:txBody>
+          <a:bodyPr wrap="square" lIns="0" tIns="0" rIns="0" bIns="0" rtlCol="0" anchor="ctr">
+            <a:normAutofit/>
+          </a:bodyPr>
+          <a:lstStyle/>
+          <a:p>
+            <a:pPr indent="0" marL="0">
+              <a:buNone/>
+            </a:pPr>
+            <a:r>
+              <a:rPr lang="en-US" sz="1000" b="1" spc="120" kern="0" dirty="0">
+                <a:solidFill>
+                  <a:srgbClr val="6E9117"/>
+                </a:solidFill>
+                <a:latin typeface="Open Sans" pitchFamily="34" charset="0"/>
+                <a:ea typeface="Open Sans" pitchFamily="34" charset="-122"/>
+                <a:cs typeface="Open Sans" pitchFamily="34" charset="-120"/>
+              </a:rPr>
+              <a:t>RECORD-LEVEL FLOW</a:t>
+            </a:r>
+            <a:endParaRPr lang="en-US" sz="1000" dirty="0"/>
+          </a:p>
+        </p:txBody>
+      </p:sp>
+      <p:sp>
+        <p:nvSpPr>
+          <p:cNvPr id="3" name="Text 1"/>
+          <p:cNvSpPr/>
+          <p:nvPr/>
+        </p:nvSpPr>
+        <p:spPr>
+          <a:xfrm>
+            <a:off x="566928" y="694944"/>
+            <a:ext cx="10972800" cy="475488"/>
+          </a:xfrm>
+          <a:prstGeom prst="rect">
+            <a:avLst/>
+          </a:prstGeom>
+          <a:noFill/>
+          <a:ln/>
+        </p:spPr>
+        <p:txBody>
+          <a:bodyPr wrap="square" lIns="0" tIns="0" rIns="0" bIns="0" rtlCol="0" anchor="ctr">
+            <a:normAutofit/>
+          </a:bodyPr>
+          <a:lstStyle/>
+          <a:p>
+            <a:pPr indent="0" marL="0">
+              <a:buNone/>
+            </a:pPr>
+            <a:r>
+              <a:rPr lang="en-US" sz="2500" b="1" dirty="0">
+                <a:solidFill>
+                  <a:srgbClr val="212529"/>
+                </a:solidFill>
+                <a:latin typeface="Open Sans" pitchFamily="34" charset="0"/>
+                <a:ea typeface="Open Sans" pitchFamily="34" charset="-122"/>
+                <a:cs typeface="Open Sans" pitchFamily="34" charset="-120"/>
+              </a:rPr>
+              <a:t>No mystery drops: every duplicate version has a disposition</a:t>
+            </a:r>
+            <a:endParaRPr lang="en-US" sz="2500" dirty="0"/>
+          </a:p>
+        </p:txBody>
+      </p:sp>
+      <p:sp>
+        <p:nvSpPr>
+          <p:cNvPr id="4" name="Text 2"/>
+          <p:cNvSpPr/>
+          <p:nvPr/>
+        </p:nvSpPr>
+        <p:spPr>
+          <a:xfrm>
+            <a:off x="566928" y="1207008"/>
+            <a:ext cx="10972800" cy="292608"/>
+          </a:xfrm>
+          <a:prstGeom prst="rect">
+            <a:avLst/>
+          </a:prstGeom>
+          <a:noFill/>
+          <a:ln/>
+        </p:spPr>
+        <p:txBody>
+          <a:bodyPr wrap="square" lIns="0" tIns="0" rIns="0" bIns="0" rtlCol="0" anchor="ctr">
+            <a:normAutofit/>
+          </a:bodyPr>
+          <a:lstStyle/>
+          <a:p>
+            <a:pPr indent="0" marL="0">
+              <a:buNone/>
+            </a:pPr>
+            <a:r>
+              <a:rPr lang="en-US" sz="1100" dirty="0">
+                <a:solidFill>
+                  <a:srgbClr val="6C757D"/>
+                </a:solidFill>
+                <a:latin typeface="Open Sans" pitchFamily="34" charset="0"/>
+                <a:ea typeface="Open Sans" pitchFamily="34" charset="-122"/>
+                <a:cs typeface="Open Sans" pitchFamily="34" charset="-120"/>
+              </a:rPr>
+              <a:t>Rows in issue categories can overlap; only displaced transaction versions leave the event fact.</a:t>
+            </a:r>
+            <a:endParaRPr lang="en-US" sz="1100" dirty="0"/>
+          </a:p>
+        </p:txBody>
+      </p:sp>
+      <p:sp>
+        <p:nvSpPr>
+          <p:cNvPr id="5" name="Shape 3"/>
+          <p:cNvSpPr/>
+          <p:nvPr/>
+        </p:nvSpPr>
+        <p:spPr>
+          <a:xfrm>
+            <a:off x="713232" y="1828800"/>
+            <a:ext cx="2240280" cy="1143000"/>
+          </a:xfrm>
+          <a:prstGeom prst="roundRect">
+            <a:avLst>
+              <a:gd name="adj" fmla="val 5600"/>
+            </a:avLst>
+          </a:prstGeom>
+          <a:solidFill>
+            <a:srgbClr val="FFFFFF"/>
+          </a:solidFill>
+          <a:ln w="10160">
+            <a:solidFill>
+              <a:srgbClr val="DEE2E6"/>
+            </a:solidFill>
+            <a:prstDash val="solid"/>
+          </a:ln>
+        </p:spPr>
+      </p:sp>
+      <p:sp>
+        <p:nvSpPr>
+          <p:cNvPr id="6" name="Text 4"/>
+          <p:cNvSpPr/>
+          <p:nvPr/>
+        </p:nvSpPr>
+        <p:spPr>
+          <a:xfrm>
+            <a:off x="859536" y="1975104"/>
+            <a:ext cx="1984248" cy="182880"/>
+          </a:xfrm>
+          <a:prstGeom prst="rect">
+            <a:avLst/>
+          </a:prstGeom>
+          <a:noFill/>
+          <a:ln/>
+        </p:spPr>
+        <p:txBody>
+          <a:bodyPr wrap="square" lIns="0" tIns="0" rIns="0" bIns="0" rtlCol="0" anchor="ctr">
+            <a:normAutofit/>
+          </a:bodyPr>
+          <a:lstStyle/>
+          <a:p>
+            <a:pPr indent="0" marL="0">
+              <a:buNone/>
+            </a:pPr>
+            <a:r>
+              <a:rPr lang="en-US" sz="900" b="1" dirty="0">
+                <a:solidFill>
+                  <a:srgbClr val="6E9117"/>
+                </a:solidFill>
+                <a:latin typeface="Open Sans" pitchFamily="34" charset="0"/>
+                <a:ea typeface="Open Sans" pitchFamily="34" charset="-122"/>
+                <a:cs typeface="Open Sans" pitchFamily="34" charset="-120"/>
+              </a:rPr>
+              <a:t>RAW CSV</a:t>
+            </a:r>
+            <a:endParaRPr lang="en-US" sz="900" dirty="0"/>
+          </a:p>
+        </p:txBody>
+      </p:sp>
+      <p:sp>
+        <p:nvSpPr>
+          <p:cNvPr id="7" name="Text 5"/>
+          <p:cNvSpPr/>
+          <p:nvPr/>
+        </p:nvSpPr>
+        <p:spPr>
+          <a:xfrm>
+            <a:off x="859536" y="2276856"/>
+            <a:ext cx="1984248" cy="310896"/>
+          </a:xfrm>
+          <a:prstGeom prst="rect">
+            <a:avLst/>
+          </a:prstGeom>
+          <a:noFill/>
+          <a:ln/>
+        </p:spPr>
+        <p:txBody>
+          <a:bodyPr wrap="square" lIns="0" tIns="0" rIns="0" bIns="0" rtlCol="0" anchor="ctr">
+            <a:normAutofit/>
+          </a:bodyPr>
+          <a:lstStyle/>
+          <a:p>
+            <a:pPr indent="0" marL="0">
+              <a:buNone/>
+            </a:pPr>
+            <a:r>
+              <a:rPr lang="en-US" sz="1900" b="1" dirty="0">
+                <a:solidFill>
+                  <a:srgbClr val="212529"/>
+                </a:solidFill>
+                <a:latin typeface="Open Sans" pitchFamily="34" charset="0"/>
+                <a:ea typeface="Open Sans" pitchFamily="34" charset="-122"/>
+                <a:cs typeface="Open Sans" pitchFamily="34" charset="-120"/>
+              </a:rPr>
+              <a:t>509,480</a:t>
+            </a:r>
+            <a:endParaRPr lang="en-US" sz="1900" dirty="0"/>
+          </a:p>
+        </p:txBody>
+      </p:sp>
+      <p:sp>
+        <p:nvSpPr>
+          <p:cNvPr id="8" name="Text 6"/>
+          <p:cNvSpPr/>
+          <p:nvPr/>
+        </p:nvSpPr>
+        <p:spPr>
+          <a:xfrm>
+            <a:off x="859536" y="2679192"/>
+            <a:ext cx="1984248" cy="164592"/>
+          </a:xfrm>
+          <a:prstGeom prst="rect">
+            <a:avLst/>
+          </a:prstGeom>
+          <a:noFill/>
+          <a:ln/>
+        </p:spPr>
+        <p:txBody>
+          <a:bodyPr wrap="square" lIns="0" tIns="0" rIns="0" bIns="0" rtlCol="0" anchor="ctr">
+            <a:normAutofit/>
+          </a:bodyPr>
+          <a:lstStyle/>
+          <a:p>
+            <a:pPr indent="0" marL="0">
+              <a:buNone/>
+            </a:pPr>
+            <a:r>
+              <a:rPr lang="en-US" sz="900" dirty="0">
+                <a:solidFill>
+                  <a:srgbClr val="6C757D"/>
+                </a:solidFill>
+                <a:latin typeface="Open Sans" pitchFamily="34" charset="0"/>
+                <a:ea typeface="Open Sans" pitchFamily="34" charset="-122"/>
+                <a:cs typeface="Open Sans" pitchFamily="34" charset="-120"/>
+              </a:rPr>
+              <a:t>Original landing rows</a:t>
+            </a:r>
+            <a:endParaRPr lang="en-US" sz="900" dirty="0"/>
+          </a:p>
+        </p:txBody>
+      </p:sp>
+      <p:sp>
+        <p:nvSpPr>
+          <p:cNvPr id="9" name="Shape 7"/>
+          <p:cNvSpPr/>
+          <p:nvPr/>
+        </p:nvSpPr>
+        <p:spPr>
+          <a:xfrm>
+            <a:off x="3447288" y="1828800"/>
+            <a:ext cx="2240280" cy="1143000"/>
+          </a:xfrm>
+          <a:prstGeom prst="roundRect">
+            <a:avLst>
+              <a:gd name="adj" fmla="val 5600"/>
+            </a:avLst>
+          </a:prstGeom>
+          <a:solidFill>
+            <a:srgbClr val="FFFFFF"/>
+          </a:solidFill>
+          <a:ln w="10160">
+            <a:solidFill>
+              <a:srgbClr val="DEE2E6"/>
+            </a:solidFill>
+            <a:prstDash val="solid"/>
+          </a:ln>
+        </p:spPr>
+      </p:sp>
+      <p:sp>
+        <p:nvSpPr>
+          <p:cNvPr id="10" name="Text 8"/>
+          <p:cNvSpPr/>
+          <p:nvPr/>
+        </p:nvSpPr>
+        <p:spPr>
+          <a:xfrm>
+            <a:off x="3593592" y="1975104"/>
+            <a:ext cx="1984248" cy="182880"/>
+          </a:xfrm>
+          <a:prstGeom prst="rect">
+            <a:avLst/>
+          </a:prstGeom>
+          <a:noFill/>
+          <a:ln/>
+        </p:spPr>
+        <p:txBody>
+          <a:bodyPr wrap="square" lIns="0" tIns="0" rIns="0" bIns="0" rtlCol="0" anchor="ctr">
+            <a:normAutofit/>
+          </a:bodyPr>
+          <a:lstStyle/>
+          <a:p>
+            <a:pPr indent="0" marL="0">
+              <a:buNone/>
+            </a:pPr>
+            <a:r>
+              <a:rPr lang="en-US" sz="900" b="1" dirty="0">
+                <a:solidFill>
+                  <a:srgbClr val="6E9117"/>
+                </a:solidFill>
+                <a:latin typeface="Open Sans" pitchFamily="34" charset="0"/>
+                <a:ea typeface="Open Sans" pitchFamily="34" charset="-122"/>
+                <a:cs typeface="Open Sans" pitchFamily="34" charset="-120"/>
+              </a:rPr>
+              <a:t>PERSISTED STAGING</a:t>
+            </a:r>
+            <a:endParaRPr lang="en-US" sz="900" dirty="0"/>
+          </a:p>
+        </p:txBody>
+      </p:sp>
+      <p:sp>
+        <p:nvSpPr>
+          <p:cNvPr id="11" name="Text 9"/>
+          <p:cNvSpPr/>
+          <p:nvPr/>
+        </p:nvSpPr>
+        <p:spPr>
+          <a:xfrm>
+            <a:off x="3593592" y="2276856"/>
+            <a:ext cx="1984248" cy="310896"/>
+          </a:xfrm>
+          <a:prstGeom prst="rect">
+            <a:avLst/>
+          </a:prstGeom>
+          <a:noFill/>
+          <a:ln/>
+        </p:spPr>
+        <p:txBody>
+          <a:bodyPr wrap="square" lIns="0" tIns="0" rIns="0" bIns="0" rtlCol="0" anchor="ctr">
+            <a:normAutofit/>
+          </a:bodyPr>
+          <a:lstStyle/>
+          <a:p>
+            <a:pPr indent="0" marL="0">
+              <a:buNone/>
+            </a:pPr>
+            <a:r>
+              <a:rPr lang="en-US" sz="1900" b="1" dirty="0">
+                <a:solidFill>
+                  <a:srgbClr val="212529"/>
+                </a:solidFill>
+                <a:latin typeface="Open Sans" pitchFamily="34" charset="0"/>
+                <a:ea typeface="Open Sans" pitchFamily="34" charset="-122"/>
+                <a:cs typeface="Open Sans" pitchFamily="34" charset="-120"/>
+              </a:rPr>
+              <a:t>509,480</a:t>
+            </a:r>
+            <a:endParaRPr lang="en-US" sz="1900" dirty="0"/>
+          </a:p>
+        </p:txBody>
+      </p:sp>
+      <p:sp>
+        <p:nvSpPr>
+          <p:cNvPr id="12" name="Text 10"/>
+          <p:cNvSpPr/>
+          <p:nvPr/>
+        </p:nvSpPr>
+        <p:spPr>
+          <a:xfrm>
+            <a:off x="3593592" y="2679192"/>
+            <a:ext cx="1984248" cy="164592"/>
+          </a:xfrm>
+          <a:prstGeom prst="rect">
+            <a:avLst/>
+          </a:prstGeom>
+          <a:noFill/>
+          <a:ln/>
+        </p:spPr>
+        <p:txBody>
+          <a:bodyPr wrap="square" lIns="0" tIns="0" rIns="0" bIns="0" rtlCol="0" anchor="ctr">
+            <a:normAutofit/>
+          </a:bodyPr>
+          <a:lstStyle/>
+          <a:p>
+            <a:pPr indent="0" marL="0">
+              <a:buNone/>
+            </a:pPr>
+            <a:r>
+              <a:rPr lang="en-US" sz="900" dirty="0">
+                <a:solidFill>
+                  <a:srgbClr val="6C757D"/>
+                </a:solidFill>
+                <a:latin typeface="Open Sans" pitchFamily="34" charset="0"/>
+                <a:ea typeface="Open Sans" pitchFamily="34" charset="-122"/>
+                <a:cs typeface="Open Sans" pitchFamily="34" charset="-120"/>
+              </a:rPr>
+              <a:t>Full table replace on rebuild</a:t>
+            </a:r>
+            <a:endParaRPr lang="en-US" sz="900" dirty="0"/>
+          </a:p>
+        </p:txBody>
+      </p:sp>
+      <p:sp>
+        <p:nvSpPr>
+          <p:cNvPr id="13" name="Shape 11"/>
+          <p:cNvSpPr/>
+          <p:nvPr/>
+        </p:nvSpPr>
+        <p:spPr>
+          <a:xfrm>
+            <a:off x="6181344" y="1828800"/>
+            <a:ext cx="2331720" cy="1143000"/>
+          </a:xfrm>
+          <a:prstGeom prst="roundRect">
+            <a:avLst>
+              <a:gd name="adj" fmla="val 5600"/>
+            </a:avLst>
+          </a:prstGeom>
+          <a:solidFill>
+            <a:srgbClr val="FFFFFF"/>
+          </a:solidFill>
+          <a:ln w="10160">
+            <a:solidFill>
+              <a:srgbClr val="DEE2E6"/>
+            </a:solidFill>
+            <a:prstDash val="solid"/>
+          </a:ln>
+        </p:spPr>
+      </p:sp>
+      <p:sp>
+        <p:nvSpPr>
+          <p:cNvPr id="14" name="Text 12"/>
+          <p:cNvSpPr/>
+          <p:nvPr/>
+        </p:nvSpPr>
+        <p:spPr>
+          <a:xfrm>
+            <a:off x="6327648" y="1975104"/>
+            <a:ext cx="2075688" cy="182880"/>
+          </a:xfrm>
+          <a:prstGeom prst="rect">
+            <a:avLst/>
+          </a:prstGeom>
+          <a:noFill/>
+          <a:ln/>
+        </p:spPr>
+        <p:txBody>
+          <a:bodyPr wrap="square" lIns="0" tIns="0" rIns="0" bIns="0" rtlCol="0" anchor="ctr">
+            <a:normAutofit/>
+          </a:bodyPr>
+          <a:lstStyle/>
+          <a:p>
+            <a:pPr indent="0" marL="0">
+              <a:buNone/>
+            </a:pPr>
+            <a:r>
+              <a:rPr lang="en-US" sz="900" b="1" dirty="0">
+                <a:solidFill>
+                  <a:srgbClr val="6E9117"/>
+                </a:solidFill>
+                <a:latin typeface="Open Sans" pitchFamily="34" charset="0"/>
+                <a:ea typeface="Open Sans" pitchFamily="34" charset="-122"/>
+                <a:cs typeface="Open Sans" pitchFamily="34" charset="-120"/>
+              </a:rPr>
+              <a:t>VERSION AUDIT</a:t>
+            </a:r>
+            <a:endParaRPr lang="en-US" sz="900" dirty="0"/>
+          </a:p>
+        </p:txBody>
+      </p:sp>
+      <p:sp>
+        <p:nvSpPr>
+          <p:cNvPr id="15" name="Text 13"/>
+          <p:cNvSpPr/>
+          <p:nvPr/>
+        </p:nvSpPr>
+        <p:spPr>
+          <a:xfrm>
+            <a:off x="6327648" y="2276856"/>
+            <a:ext cx="2075688" cy="310896"/>
+          </a:xfrm>
+          <a:prstGeom prst="rect">
+            <a:avLst/>
+          </a:prstGeom>
+          <a:noFill/>
+          <a:ln/>
+        </p:spPr>
+        <p:txBody>
+          <a:bodyPr wrap="square" lIns="0" tIns="0" rIns="0" bIns="0" rtlCol="0" anchor="ctr">
+            <a:normAutofit/>
+          </a:bodyPr>
+          <a:lstStyle/>
+          <a:p>
+            <a:pPr indent="0" marL="0">
+              <a:buNone/>
+            </a:pPr>
+            <a:r>
+              <a:rPr lang="en-US" sz="1900" b="1" dirty="0">
+                <a:solidFill>
+                  <a:srgbClr val="212529"/>
+                </a:solidFill>
+                <a:latin typeface="Open Sans" pitchFamily="34" charset="0"/>
+                <a:ea typeface="Open Sans" pitchFamily="34" charset="-122"/>
+                <a:cs typeface="Open Sans" pitchFamily="34" charset="-120"/>
+              </a:rPr>
+              <a:t>509,480</a:t>
+            </a:r>
+            <a:endParaRPr lang="en-US" sz="1900" dirty="0"/>
+          </a:p>
+        </p:txBody>
+      </p:sp>
+      <p:sp>
+        <p:nvSpPr>
+          <p:cNvPr id="16" name="Text 14"/>
+          <p:cNvSpPr/>
+          <p:nvPr/>
+        </p:nvSpPr>
+        <p:spPr>
+          <a:xfrm>
+            <a:off x="6327648" y="2679192"/>
+            <a:ext cx="2075688" cy="164592"/>
+          </a:xfrm>
+          <a:prstGeom prst="rect">
+            <a:avLst/>
+          </a:prstGeom>
+          <a:noFill/>
+          <a:ln/>
+        </p:spPr>
+        <p:txBody>
+          <a:bodyPr wrap="square" lIns="0" tIns="0" rIns="0" bIns="0" rtlCol="0" anchor="ctr">
+            <a:normAutofit/>
+          </a:bodyPr>
+          <a:lstStyle/>
+          <a:p>
+            <a:pPr indent="0" marL="0">
+              <a:buNone/>
+            </a:pPr>
+            <a:r>
+              <a:rPr lang="en-US" sz="900" dirty="0">
+                <a:solidFill>
+                  <a:srgbClr val="6C757D"/>
+                </a:solidFill>
+                <a:latin typeface="Open Sans" pitchFamily="34" charset="0"/>
+                <a:ea typeface="Open Sans" pitchFamily="34" charset="-122"/>
+                <a:cs typeface="Open Sans" pitchFamily="34" charset="-120"/>
+              </a:rPr>
+              <a:t>Ranked, none appended</a:t>
+            </a:r>
+            <a:endParaRPr lang="en-US" sz="900" dirty="0"/>
+          </a:p>
+        </p:txBody>
+      </p:sp>
+      <p:sp>
+        <p:nvSpPr>
+          <p:cNvPr id="17" name="Shape 15"/>
+          <p:cNvSpPr/>
+          <p:nvPr/>
+        </p:nvSpPr>
+        <p:spPr>
+          <a:xfrm>
+            <a:off x="9006840" y="1828800"/>
+            <a:ext cx="2432304" cy="1143000"/>
+          </a:xfrm>
+          <a:prstGeom prst="roundRect">
+            <a:avLst>
+              <a:gd name="adj" fmla="val 5600"/>
+            </a:avLst>
+          </a:prstGeom>
+          <a:solidFill>
+            <a:srgbClr val="FFFFFF"/>
+          </a:solidFill>
+          <a:ln w="10160">
+            <a:solidFill>
+              <a:srgbClr val="DEE2E6"/>
+            </a:solidFill>
+            <a:prstDash val="solid"/>
+          </a:ln>
+        </p:spPr>
+      </p:sp>
+      <p:sp>
+        <p:nvSpPr>
+          <p:cNvPr id="18" name="Text 16"/>
+          <p:cNvSpPr/>
+          <p:nvPr/>
+        </p:nvSpPr>
+        <p:spPr>
+          <a:xfrm>
+            <a:off x="9153144" y="1975104"/>
+            <a:ext cx="2176272" cy="182880"/>
+          </a:xfrm>
+          <a:prstGeom prst="rect">
+            <a:avLst/>
+          </a:prstGeom>
+          <a:noFill/>
+          <a:ln/>
+        </p:spPr>
+        <p:txBody>
+          <a:bodyPr wrap="square" lIns="0" tIns="0" rIns="0" bIns="0" rtlCol="0" anchor="ctr">
+            <a:normAutofit/>
+          </a:bodyPr>
+          <a:lstStyle/>
+          <a:p>
+            <a:pPr indent="0" marL="0">
+              <a:buNone/>
+            </a:pPr>
+            <a:r>
+              <a:rPr lang="en-US" sz="900" b="1" dirty="0">
+                <a:solidFill>
+                  <a:srgbClr val="6E9117"/>
+                </a:solidFill>
+                <a:latin typeface="Open Sans" pitchFamily="34" charset="0"/>
+                <a:ea typeface="Open Sans" pitchFamily="34" charset="-122"/>
+                <a:cs typeface="Open Sans" pitchFamily="34" charset="-120"/>
+              </a:rPr>
+              <a:t>EVENT FACT</a:t>
+            </a:r>
+            <a:endParaRPr lang="en-US" sz="900" dirty="0"/>
+          </a:p>
+        </p:txBody>
+      </p:sp>
+      <p:sp>
+        <p:nvSpPr>
+          <p:cNvPr id="19" name="Text 17"/>
+          <p:cNvSpPr/>
+          <p:nvPr/>
+        </p:nvSpPr>
+        <p:spPr>
+          <a:xfrm>
+            <a:off x="9153144" y="2276856"/>
+            <a:ext cx="2176272" cy="310896"/>
+          </a:xfrm>
+          <a:prstGeom prst="rect">
+            <a:avLst/>
+          </a:prstGeom>
+          <a:noFill/>
+          <a:ln/>
+        </p:spPr>
+        <p:txBody>
+          <a:bodyPr wrap="square" lIns="0" tIns="0" rIns="0" bIns="0" rtlCol="0" anchor="ctr">
+            <a:normAutofit/>
+          </a:bodyPr>
+          <a:lstStyle/>
+          <a:p>
+            <a:pPr indent="0" marL="0">
+              <a:buNone/>
+            </a:pPr>
+            <a:r>
+              <a:rPr lang="en-US" sz="1900" b="1" dirty="0">
+                <a:solidFill>
+                  <a:srgbClr val="212529"/>
+                </a:solidFill>
+                <a:latin typeface="Open Sans" pitchFamily="34" charset="0"/>
+                <a:ea typeface="Open Sans" pitchFamily="34" charset="-122"/>
+                <a:cs typeface="Open Sans" pitchFamily="34" charset="-120"/>
+              </a:rPr>
+              <a:t>499,665</a:t>
+            </a:r>
+            <a:endParaRPr lang="en-US" sz="1900" dirty="0"/>
+          </a:p>
+        </p:txBody>
+      </p:sp>
+      <p:sp>
+        <p:nvSpPr>
+          <p:cNvPr id="20" name="Text 18"/>
+          <p:cNvSpPr/>
+          <p:nvPr/>
+        </p:nvSpPr>
+        <p:spPr>
+          <a:xfrm>
+            <a:off x="9153144" y="2679192"/>
+            <a:ext cx="2176272" cy="164592"/>
+          </a:xfrm>
+          <a:prstGeom prst="rect">
+            <a:avLst/>
+          </a:prstGeom>
+          <a:noFill/>
+          <a:ln/>
+        </p:spPr>
+        <p:txBody>
+          <a:bodyPr wrap="square" lIns="0" tIns="0" rIns="0" bIns="0" rtlCol="0" anchor="ctr">
+            <a:normAutofit/>
+          </a:bodyPr>
+          <a:lstStyle/>
+          <a:p>
+            <a:pPr indent="0" marL="0">
+              <a:buNone/>
+            </a:pPr>
+            <a:r>
+              <a:rPr lang="en-US" sz="900" dirty="0">
+                <a:solidFill>
+                  <a:srgbClr val="6C757D"/>
+                </a:solidFill>
+                <a:latin typeface="Open Sans" pitchFamily="34" charset="0"/>
+                <a:ea typeface="Open Sans" pitchFamily="34" charset="-122"/>
+                <a:cs typeface="Open Sans" pitchFamily="34" charset="-120"/>
+              </a:rPr>
+              <a:t>One selected row per ID</a:t>
+            </a:r>
+            <a:endParaRPr lang="en-US" sz="900" dirty="0"/>
+          </a:p>
+        </p:txBody>
+      </p:sp>
+      <p:sp>
+        <p:nvSpPr>
+          <p:cNvPr id="21" name="Shape 19"/>
+          <p:cNvSpPr/>
+          <p:nvPr/>
+        </p:nvSpPr>
+        <p:spPr>
+          <a:xfrm>
+            <a:off x="3026664" y="2404872"/>
+            <a:ext cx="347472" cy="0"/>
+          </a:xfrm>
+          <a:prstGeom prst="line">
+            <a:avLst/>
+          </a:prstGeom>
+          <a:noFill/>
+          <a:ln w="22860">
+            <a:solidFill>
+              <a:srgbClr val="6E9117"/>
+            </a:solidFill>
+            <a:prstDash val="solid"/>
+            <a:tailEnd type="triangle"/>
+          </a:ln>
+        </p:spPr>
+      </p:sp>
+      <p:sp>
+        <p:nvSpPr>
+          <p:cNvPr id="22" name="Shape 20"/>
+          <p:cNvSpPr/>
+          <p:nvPr/>
+        </p:nvSpPr>
+        <p:spPr>
+          <a:xfrm>
+            <a:off x="5760720" y="2404872"/>
+            <a:ext cx="347472" cy="0"/>
+          </a:xfrm>
+          <a:prstGeom prst="line">
+            <a:avLst/>
+          </a:prstGeom>
+          <a:noFill/>
+          <a:ln w="22860">
+            <a:solidFill>
+              <a:srgbClr val="6E9117"/>
+            </a:solidFill>
+            <a:prstDash val="solid"/>
+            <a:tailEnd type="triangle"/>
+          </a:ln>
+        </p:spPr>
+      </p:sp>
+      <p:sp>
+        <p:nvSpPr>
+          <p:cNvPr id="23" name="Shape 21"/>
+          <p:cNvSpPr/>
+          <p:nvPr/>
+        </p:nvSpPr>
+        <p:spPr>
+          <a:xfrm>
+            <a:off x="8586216" y="2404872"/>
+            <a:ext cx="347472" cy="0"/>
+          </a:xfrm>
+          <a:prstGeom prst="line">
+            <a:avLst/>
+          </a:prstGeom>
+          <a:noFill/>
+          <a:ln w="22860">
+            <a:solidFill>
+              <a:srgbClr val="6E9117"/>
+            </a:solidFill>
+            <a:prstDash val="solid"/>
+            <a:tailEnd type="triangle"/>
+          </a:ln>
+        </p:spPr>
+      </p:sp>
+      <p:sp>
+        <p:nvSpPr>
+          <p:cNvPr id="24" name="Shape 22"/>
+          <p:cNvSpPr/>
+          <p:nvPr/>
+        </p:nvSpPr>
+        <p:spPr>
+          <a:xfrm>
+            <a:off x="3474720" y="3493008"/>
+            <a:ext cx="3749040" cy="914400"/>
+          </a:xfrm>
+          <a:prstGeom prst="roundRect">
+            <a:avLst>
+              <a:gd name="adj" fmla="val 7000"/>
+            </a:avLst>
+          </a:prstGeom>
+          <a:solidFill>
+            <a:srgbClr val="F8E9E7"/>
+          </a:solidFill>
+          <a:ln w="12700">
+            <a:solidFill>
+              <a:srgbClr val="F8E9E7">
+                <a:alpha val="0"/>
+              </a:srgbClr>
+            </a:solidFill>
+            <a:prstDash val="solid"/>
+          </a:ln>
+        </p:spPr>
+      </p:sp>
+      <p:sp>
+        <p:nvSpPr>
+          <p:cNvPr id="25" name="Text 23"/>
+          <p:cNvSpPr/>
+          <p:nvPr/>
+        </p:nvSpPr>
+        <p:spPr>
+          <a:xfrm>
+            <a:off x="3657600" y="3639312"/>
+            <a:ext cx="3429000" cy="256032"/>
+          </a:xfrm>
+          <a:prstGeom prst="rect">
+            <a:avLst/>
+          </a:prstGeom>
+          <a:noFill/>
+          <a:ln/>
+        </p:spPr>
+        <p:txBody>
+          <a:bodyPr wrap="square" lIns="0" tIns="0" rIns="0" bIns="0" rtlCol="0" anchor="ctr">
+            <a:normAutofit/>
+          </a:bodyPr>
+          <a:lstStyle/>
+          <a:p>
+            <a:pPr indent="0" marL="0">
+              <a:buNone/>
+            </a:pPr>
+            <a:r>
+              <a:rPr lang="en-US" sz="1500" b="1" dirty="0">
+                <a:solidFill>
+                  <a:srgbClr val="B5473A"/>
+                </a:solidFill>
+                <a:latin typeface="Open Sans" pitchFamily="34" charset="0"/>
+                <a:ea typeface="Open Sans" pitchFamily="34" charset="-122"/>
+                <a:cs typeface="Open Sans" pitchFamily="34" charset="-120"/>
+              </a:rPr>
+              <a:t>19,630 duplicate-version rows</a:t>
+            </a:r>
+            <a:endParaRPr lang="en-US" sz="1500" dirty="0"/>
+          </a:p>
+        </p:txBody>
+      </p:sp>
+      <p:sp>
+        <p:nvSpPr>
+          <p:cNvPr id="26" name="Text 24"/>
+          <p:cNvSpPr/>
+          <p:nvPr/>
+        </p:nvSpPr>
+        <p:spPr>
+          <a:xfrm>
+            <a:off x="3657600" y="3995928"/>
+            <a:ext cx="3383280" cy="228600"/>
+          </a:xfrm>
+          <a:prstGeom prst="rect">
+            <a:avLst/>
+          </a:prstGeom>
+          <a:noFill/>
+          <a:ln/>
+        </p:spPr>
+        <p:txBody>
+          <a:bodyPr wrap="square" lIns="0" tIns="0" rIns="0" bIns="0" rtlCol="0" anchor="ctr">
+            <a:normAutofit/>
+          </a:bodyPr>
+          <a:lstStyle/>
+          <a:p>
+            <a:pPr indent="0" marL="0">
+              <a:buNone/>
+            </a:pPr>
+            <a:r>
+              <a:rPr lang="en-US" sz="900" dirty="0">
+                <a:solidFill>
+                  <a:srgbClr val="6C757D"/>
+                </a:solidFill>
+                <a:latin typeface="Open Sans" pitchFamily="34" charset="0"/>
+                <a:ea typeface="Open Sans" pitchFamily="34" charset="-122"/>
+                <a:cs typeface="Open Sans" pitchFamily="34" charset="-120"/>
+              </a:rPr>
+              <a:t>9,815 IDs x 2 versions; both versions are logged in triage.</a:t>
+            </a:r>
+            <a:endParaRPr lang="en-US" sz="900" dirty="0"/>
+          </a:p>
+        </p:txBody>
+      </p:sp>
+      <p:sp>
+        <p:nvSpPr>
+          <p:cNvPr id="27" name="Shape 25"/>
+          <p:cNvSpPr/>
+          <p:nvPr/>
+        </p:nvSpPr>
+        <p:spPr>
+          <a:xfrm>
+            <a:off x="7635240" y="3493008"/>
+            <a:ext cx="3730752" cy="914400"/>
+          </a:xfrm>
+          <a:prstGeom prst="roundRect">
+            <a:avLst>
+              <a:gd name="adj" fmla="val 7000"/>
+            </a:avLst>
+          </a:prstGeom>
+          <a:solidFill>
+            <a:srgbClr val="E7EDF4"/>
+          </a:solidFill>
+          <a:ln w="12700">
+            <a:solidFill>
+              <a:srgbClr val="E7EDF4">
+                <a:alpha val="0"/>
+              </a:srgbClr>
+            </a:solidFill>
+            <a:prstDash val="solid"/>
+          </a:ln>
+        </p:spPr>
+      </p:sp>
+      <p:sp>
+        <p:nvSpPr>
+          <p:cNvPr id="28" name="Text 26"/>
+          <p:cNvSpPr/>
+          <p:nvPr/>
+        </p:nvSpPr>
+        <p:spPr>
+          <a:xfrm>
+            <a:off x="7827264" y="3639312"/>
+            <a:ext cx="3383280" cy="256032"/>
+          </a:xfrm>
+          <a:prstGeom prst="rect">
+            <a:avLst/>
+          </a:prstGeom>
+          <a:noFill/>
+          <a:ln/>
+        </p:spPr>
+        <p:txBody>
+          <a:bodyPr wrap="square" lIns="0" tIns="0" rIns="0" bIns="0" rtlCol="0" anchor="ctr">
+            <a:normAutofit/>
+          </a:bodyPr>
+          <a:lstStyle/>
+          <a:p>
+            <a:pPr indent="0" marL="0">
+              <a:buNone/>
+            </a:pPr>
+            <a:r>
+              <a:rPr lang="en-US" sz="1500" b="1" dirty="0">
+                <a:solidFill>
+                  <a:srgbClr val="30445C"/>
+                </a:solidFill>
+                <a:latin typeface="Open Sans" pitchFamily="34" charset="0"/>
+                <a:ea typeface="Open Sans" pitchFamily="34" charset="-122"/>
+                <a:cs typeface="Open Sans" pitchFamily="34" charset="-120"/>
+              </a:rPr>
+              <a:t>9,815 versions excluded</a:t>
+            </a:r>
+            <a:endParaRPr lang="en-US" sz="1500" dirty="0"/>
+          </a:p>
+        </p:txBody>
+      </p:sp>
+      <p:sp>
+        <p:nvSpPr>
+          <p:cNvPr id="29" name="Text 27"/>
+          <p:cNvSpPr/>
+          <p:nvPr/>
+        </p:nvSpPr>
+        <p:spPr>
+          <a:xfrm>
+            <a:off x="7827264" y="3995928"/>
+            <a:ext cx="3383280" cy="228600"/>
+          </a:xfrm>
+          <a:prstGeom prst="rect">
+            <a:avLst/>
+          </a:prstGeom>
+          <a:noFill/>
+          <a:ln/>
+        </p:spPr>
+        <p:txBody>
+          <a:bodyPr wrap="square" lIns="0" tIns="0" rIns="0" bIns="0" rtlCol="0" anchor="ctr">
+            <a:normAutofit/>
+          </a:bodyPr>
+          <a:lstStyle/>
+          <a:p>
+            <a:pPr indent="0" marL="0">
+              <a:buNone/>
+            </a:pPr>
+            <a:r>
+              <a:rPr lang="en-US" sz="900" dirty="0">
+                <a:solidFill>
+                  <a:srgbClr val="6C757D"/>
+                </a:solidFill>
+                <a:latin typeface="Open Sans" pitchFamily="34" charset="0"/>
+                <a:ea typeface="Open Sans" pitchFamily="34" charset="-122"/>
+                <a:cs typeface="Open Sans" pitchFamily="34" charset="-120"/>
+              </a:rPr>
+              <a:t>Latest version retained; older rows remain queryable in the audit.</a:t>
+            </a:r>
+            <a:endParaRPr lang="en-US" sz="900" dirty="0"/>
+          </a:p>
+        </p:txBody>
+      </p:sp>
+      <p:sp>
+        <p:nvSpPr>
+          <p:cNvPr id="30" name="Text 28"/>
+          <p:cNvSpPr/>
+          <p:nvPr/>
+        </p:nvSpPr>
+        <p:spPr>
+          <a:xfrm>
+            <a:off x="868680" y="4828032"/>
+            <a:ext cx="10424160" cy="292608"/>
+          </a:xfrm>
+          <a:prstGeom prst="rect">
+            <a:avLst/>
+          </a:prstGeom>
+          <a:noFill/>
+          <a:ln/>
+        </p:spPr>
+        <p:txBody>
+          <a:bodyPr wrap="square" lIns="0" tIns="0" rIns="0" bIns="0" rtlCol="0" anchor="ctr">
+            <a:normAutofit/>
+          </a:bodyPr>
+          <a:lstStyle/>
+          <a:p>
+            <a:pPr indent="0" marL="0">
+              <a:buNone/>
+            </a:pPr>
+            <a:r>
+              <a:rPr lang="en-US" sz="1200" b="1" dirty="0">
+                <a:solidFill>
+                  <a:srgbClr val="212529"/>
+                </a:solidFill>
+                <a:latin typeface="Open Sans" pitchFamily="34" charset="0"/>
+                <a:ea typeface="Open Sans" pitchFamily="34" charset="-122"/>
+                <a:cs typeface="Open Sans" pitchFamily="34" charset="-120"/>
+              </a:rPr>
+              <a:t>28,668 total issue rows / 28,563 distinct source rows flagged (categories overlap).</a:t>
+            </a:r>
+            <a:endParaRPr lang="en-US" sz="1200" dirty="0"/>
+          </a:p>
+        </p:txBody>
+      </p:sp>
+      <p:sp>
+        <p:nvSpPr>
+          <p:cNvPr id="31" name="Text 29"/>
+          <p:cNvSpPr/>
+          <p:nvPr/>
+        </p:nvSpPr>
+        <p:spPr>
+          <a:xfrm>
+            <a:off x="868680" y="5285232"/>
+            <a:ext cx="10424160" cy="502920"/>
+          </a:xfrm>
+          <a:prstGeom prst="rect">
+            <a:avLst/>
+          </a:prstGeom>
+          <a:noFill/>
+          <a:ln/>
+        </p:spPr>
+        <p:txBody>
+          <a:bodyPr wrap="square" lIns="0" tIns="0" rIns="0" bIns="0" rtlCol="0" anchor="t">
+            <a:normAutofit/>
+          </a:bodyPr>
+          <a:lstStyle/>
+          <a:p>
+            <a:pPr indent="0" marL="0">
+              <a:buNone/>
+            </a:pPr>
+            <a:r>
+              <a:rPr lang="en-US" sz="1000" dirty="0">
+                <a:solidFill>
+                  <a:srgbClr val="6C757D"/>
+                </a:solidFill>
+                <a:latin typeface="Open Sans" pitchFamily="34" charset="0"/>
+                <a:ea typeface="Open Sans" pitchFamily="34" charset="-122"/>
+                <a:cs typeface="Open Sans" pitchFamily="34" charset="-120"/>
+              </a:rPr>
+              <a:t>Unknown keys, missing costs, negative quantities and attribute conflicts are retained/flagged, not dropped. Only 9,815 displaced ID versions are excluded from the fact.</a:t>
+            </a:r>
+            <a:endParaRPr lang="en-US" sz="1000" dirty="0"/>
+          </a:p>
+        </p:txBody>
+      </p:sp>
+      <p:sp>
+        <p:nvSpPr>
+          <p:cNvPr id="25" name="Slide Number Placeholder 0"/>
+          <p:cNvSpPr>
+            <a:spLocks noGrp="1"/>
+          </p:cNvSpPr>
+          <p:nvPr>
+            <p:ph type="sldNum" sz="quarter" idx="4294967295"/>
+          </p:nvPr>
+        </p:nvSpPr>
+        <p:spPr>
+          <a:xfrm>
+            <a:off x="11201400" y="6473952"/>
+            <a:ext cx="800000" cy="300000"/>
+          </a:xfrm>
+          <a:prstGeom prst="rect">
+            <a:avLst/>
+          </a:prstGeom>
+          <a:extLst>
+            <a:ext uri="{C572A759-6A51-4108-AA02-DFA0A04FC94B}">
+              <ma14:wrappingTextBoxFlag xmlns:ma14="http://schemas.microsoft.com/office/mac/drawingml/2011/main" val="0"/>
+            </a:ext>
+          </a:extLst>
+        </p:spPr>
+        <p:txBody>
+          <a:bodyPr/>
+          <a:lstStyle>
+            <a:lvl1pPr>
+              <a:defRPr sz="900">
+                <a:solidFill>
+                  <a:srgbClr val="6C757D"/>
+                </a:solidFill>
+                <a:latin typeface="Open Sans"/>
+                <a:ea typeface="Open Sans"/>
+                <a:cs typeface="Open Sans"/>
+              </a:defRPr>
+            </a:lvl1pPr>
+          </a:lstStyle>
+          <a:p>
+            <a:pPr algn="l"/>
+            <a:fld id="{F7021451-1387-4CA6-816F-3879F97B5CBC}" type="slidenum">
+              <a:rPr b="0" lang="en-US"/>
+              <a:t>10</a:t>
+            </a:fld>
+            <a:endParaRPr lang="en-US"/>
+          </a:p>
+        </p:txBody>
+      </p:sp>
+    </p:spTree>
+  </p:cSld>
+  <p:clrMapOvr>
+    <a:masterClrMapping/>
+  </p:clrMapOvr>
+</p:sld>
+</file>
+
+<file path=ppt/slides/slide11.xml><?xml version="1.0" encoding="utf-8"?>
+<p:sld xmlns:a="http://schemas.openxmlformats.org/drawingml/2006/main" xmlns:r="http://schemas.openxmlformats.org/officeDocument/2006/relationships" xmlns:p="http://schemas.openxmlformats.org/presentationml/2006/main">
+  <p:cSld name="Slide 11">
+    <p:spTree>
+      <p:nvGrpSpPr>
+        <p:cNvPr id="1" name=""/>
+        <p:cNvGrpSpPr/>
+        <p:nvPr/>
+      </p:nvGrpSpPr>
+      <p:grpSpPr>
+        <a:xfrm>
+          <a:off x="0" y="0"/>
+          <a:ext cx="0" cy="0"/>
+          <a:chOff x="0" y="0"/>
+          <a:chExt cx="0" cy="0"/>
+        </a:xfrm>
+      </p:grpSpPr>
+      <p:sp>
+        <p:nvSpPr>
+          <p:cNvPr id="2" name="Text 0"/>
+          <p:cNvSpPr/>
+          <p:nvPr/>
+        </p:nvSpPr>
+        <p:spPr>
+          <a:xfrm>
+            <a:off x="566928" y="384048"/>
+            <a:ext cx="10789920" cy="219456"/>
+          </a:xfrm>
+          <a:prstGeom prst="rect">
+            <a:avLst/>
+          </a:prstGeom>
+          <a:noFill/>
+          <a:ln/>
+        </p:spPr>
+        <p:txBody>
+          <a:bodyPr wrap="square" lIns="0" tIns="0" rIns="0" bIns="0" rtlCol="0" anchor="ctr">
+            <a:normAutofit/>
+          </a:bodyPr>
+          <a:lstStyle/>
+          <a:p>
+            <a:pPr indent="0" marL="0">
+              <a:buNone/>
+            </a:pPr>
+            <a:r>
+              <a:rPr lang="en-US" sz="1000" b="1" spc="120" kern="0" dirty="0">
+                <a:solidFill>
+                  <a:srgbClr val="6E9117"/>
+                </a:solidFill>
+                <a:latin typeface="Open Sans" pitchFamily="34" charset="0"/>
+                <a:ea typeface="Open Sans" pitchFamily="34" charset="-122"/>
+                <a:cs typeface="Open Sans" pitchFamily="34" charset="-120"/>
+              </a:rPr>
+              <a:t>STAR SCHEMA AND DRILL PATHS</a:t>
+            </a:r>
+            <a:endParaRPr lang="en-US" sz="1000" dirty="0"/>
+          </a:p>
+        </p:txBody>
+      </p:sp>
+      <p:sp>
+        <p:nvSpPr>
+          <p:cNvPr id="3" name="Text 1"/>
+          <p:cNvSpPr/>
+          <p:nvPr/>
+        </p:nvSpPr>
+        <p:spPr>
+          <a:xfrm>
+            <a:off x="566928" y="694944"/>
+            <a:ext cx="10972800" cy="475488"/>
+          </a:xfrm>
+          <a:prstGeom prst="rect">
+            <a:avLst/>
+          </a:prstGeom>
+          <a:noFill/>
+          <a:ln/>
+        </p:spPr>
+        <p:txBody>
+          <a:bodyPr wrap="square" lIns="0" tIns="0" rIns="0" bIns="0" rtlCol="0" anchor="ctr">
+            <a:normAutofit/>
+          </a:bodyPr>
+          <a:lstStyle/>
+          <a:p>
+            <a:pPr indent="0" marL="0">
+              <a:buNone/>
+            </a:pPr>
+            <a:r>
+              <a:rPr lang="en-US" sz="2500" b="1" dirty="0">
+                <a:solidFill>
+                  <a:srgbClr val="212529"/>
+                </a:solidFill>
+                <a:latin typeface="Open Sans" pitchFamily="34" charset="0"/>
+                <a:ea typeface="Open Sans" pitchFamily="34" charset="-122"/>
+                <a:cs typeface="Open Sans" pitchFamily="34" charset="-120"/>
+              </a:rPr>
+              <a:t>Three dimensions; one event fact; no fake snapshot</a:t>
+            </a:r>
+            <a:endParaRPr lang="en-US" sz="2500" dirty="0"/>
+          </a:p>
+        </p:txBody>
+      </p:sp>
+      <p:sp>
+        <p:nvSpPr>
+          <p:cNvPr id="4" name="Text 2"/>
+          <p:cNvSpPr/>
+          <p:nvPr/>
+        </p:nvSpPr>
+        <p:spPr>
+          <a:xfrm>
+            <a:off x="566928" y="1207008"/>
+            <a:ext cx="10972800" cy="292608"/>
+          </a:xfrm>
+          <a:prstGeom prst="rect">
+            <a:avLst/>
+          </a:prstGeom>
+          <a:noFill/>
+          <a:ln/>
+        </p:spPr>
+        <p:txBody>
+          <a:bodyPr wrap="square" lIns="0" tIns="0" rIns="0" bIns="0" rtlCol="0" anchor="ctr">
+            <a:normAutofit/>
+          </a:bodyPr>
+          <a:lstStyle/>
+          <a:p>
+            <a:pPr indent="0" marL="0">
+              <a:buNone/>
+            </a:pPr>
+            <a:r>
+              <a:rPr lang="en-US" sz="1100" dirty="0">
+                <a:solidFill>
+                  <a:srgbClr val="6C757D"/>
+                </a:solidFill>
+                <a:latin typeface="Open Sans" pitchFamily="34" charset="0"/>
+                <a:ea typeface="Open Sans" pitchFamily="34" charset="-122"/>
+                <a:cs typeface="Open Sans" pitchFamily="34" charset="-120"/>
+              </a:rPr>
+              <a:t>Date filters are standard for reporting, but an event fact does not require every query to specify a range.</a:t>
+            </a:r>
+            <a:endParaRPr lang="en-US" sz="1100" dirty="0"/>
+          </a:p>
+        </p:txBody>
+      </p:sp>
+      <p:sp>
+        <p:nvSpPr>
+          <p:cNvPr id="5" name="Shape 3"/>
+          <p:cNvSpPr/>
+          <p:nvPr/>
+        </p:nvSpPr>
+        <p:spPr>
+          <a:xfrm>
+            <a:off x="713232" y="1755648"/>
+            <a:ext cx="3456432" cy="1234440"/>
+          </a:xfrm>
+          <a:prstGeom prst="roundRect">
+            <a:avLst>
+              <a:gd name="adj" fmla="val 5926"/>
+            </a:avLst>
+          </a:prstGeom>
+          <a:solidFill>
+            <a:srgbClr val="FFFFFF"/>
+          </a:solidFill>
+          <a:ln w="10160">
+            <a:solidFill>
+              <a:srgbClr val="DEE2E6"/>
+            </a:solidFill>
+            <a:prstDash val="solid"/>
+          </a:ln>
+        </p:spPr>
+      </p:sp>
+      <p:sp>
+        <p:nvSpPr>
+          <p:cNvPr id="6" name="Shape 4"/>
+          <p:cNvSpPr/>
+          <p:nvPr/>
+        </p:nvSpPr>
+        <p:spPr>
+          <a:xfrm>
+            <a:off x="713232" y="1755648"/>
+            <a:ext cx="73152" cy="1234440"/>
+          </a:xfrm>
+          <a:prstGeom prst="rect">
+            <a:avLst/>
+          </a:prstGeom>
+          <a:solidFill>
+            <a:srgbClr val="95C11F"/>
+          </a:solidFill>
+          <a:ln w="12700">
+            <a:solidFill>
+              <a:srgbClr val="95C11F">
+                <a:alpha val="0"/>
+              </a:srgbClr>
+            </a:solidFill>
+            <a:prstDash val="solid"/>
+          </a:ln>
+        </p:spPr>
+      </p:sp>
+      <p:sp>
+        <p:nvSpPr>
+          <p:cNvPr id="7" name="Text 5"/>
+          <p:cNvSpPr/>
+          <p:nvPr/>
+        </p:nvSpPr>
+        <p:spPr>
+          <a:xfrm>
+            <a:off x="914400" y="1901952"/>
+            <a:ext cx="3090672" cy="228600"/>
+          </a:xfrm>
+          <a:prstGeom prst="rect">
+            <a:avLst/>
+          </a:prstGeom>
+          <a:noFill/>
+          <a:ln/>
+        </p:spPr>
+        <p:txBody>
+          <a:bodyPr wrap="square" lIns="0" tIns="0" rIns="0" bIns="0" rtlCol="0" anchor="ctr">
+            <a:normAutofit/>
+          </a:bodyPr>
+          <a:lstStyle/>
+          <a:p>
+            <a:pPr indent="0" marL="0">
+              <a:buNone/>
+            </a:pPr>
+            <a:r>
+              <a:rPr lang="en-US" sz="900" b="1" dirty="0">
+                <a:solidFill>
+                  <a:srgbClr val="6C757D"/>
+                </a:solidFill>
+                <a:latin typeface="Open Sans" pitchFamily="34" charset="0"/>
+                <a:ea typeface="Open Sans" pitchFamily="34" charset="-122"/>
+                <a:cs typeface="Open Sans" pitchFamily="34" charset="-120"/>
+              </a:rPr>
+              <a:t>DIM_DATE</a:t>
+            </a:r>
+            <a:endParaRPr lang="en-US" sz="900" dirty="0"/>
+          </a:p>
+        </p:txBody>
+      </p:sp>
+      <p:sp>
+        <p:nvSpPr>
+          <p:cNvPr id="8" name="Text 6"/>
+          <p:cNvSpPr/>
+          <p:nvPr/>
+        </p:nvSpPr>
+        <p:spPr>
+          <a:xfrm>
+            <a:off x="914400" y="2240280"/>
+            <a:ext cx="3090672" cy="438912"/>
+          </a:xfrm>
+          <a:prstGeom prst="rect">
+            <a:avLst/>
+          </a:prstGeom>
+          <a:noFill/>
+          <a:ln/>
+        </p:spPr>
+        <p:txBody>
+          <a:bodyPr wrap="square" lIns="0" tIns="0" rIns="0" bIns="0" rtlCol="0" anchor="ctr">
+            <a:normAutofit/>
+          </a:bodyPr>
+          <a:lstStyle/>
+          <a:p>
+            <a:pPr indent="0" marL="0">
+              <a:buNone/>
+            </a:pPr>
+            <a:r>
+              <a:rPr lang="en-US" sz="2300" b="1" dirty="0">
+                <a:solidFill>
+                  <a:srgbClr val="212529"/>
+                </a:solidFill>
+                <a:latin typeface="Open Sans" pitchFamily="34" charset="0"/>
+                <a:ea typeface="Open Sans" pitchFamily="34" charset="-122"/>
+                <a:cs typeface="Open Sans" pitchFamily="34" charset="-120"/>
+              </a:rPr>
+              <a:t>1,461</a:t>
+            </a:r>
+            <a:endParaRPr lang="en-US" sz="2300" dirty="0"/>
+          </a:p>
+        </p:txBody>
+      </p:sp>
+      <p:sp>
+        <p:nvSpPr>
+          <p:cNvPr id="9" name="Text 7"/>
+          <p:cNvSpPr/>
+          <p:nvPr/>
+        </p:nvSpPr>
+        <p:spPr>
+          <a:xfrm>
+            <a:off x="914400" y="2734056"/>
+            <a:ext cx="3090672" cy="155448"/>
+          </a:xfrm>
+          <a:prstGeom prst="rect">
+            <a:avLst/>
+          </a:prstGeom>
+          <a:noFill/>
+          <a:ln/>
+        </p:spPr>
+        <p:txBody>
+          <a:bodyPr wrap="square" lIns="0" tIns="0" rIns="0" bIns="0" rtlCol="0" anchor="t">
+            <a:normAutofit/>
+          </a:bodyPr>
+          <a:lstStyle/>
+          <a:p>
+            <a:pPr indent="0" marL="0">
+              <a:buNone/>
+            </a:pPr>
+            <a:r>
+              <a:rPr lang="en-US" sz="1000" dirty="0">
+                <a:solidFill>
+                  <a:srgbClr val="6C757D"/>
+                </a:solidFill>
+                <a:latin typeface="Open Sans" pitchFamily="34" charset="0"/>
+                <a:ea typeface="Open Sans" pitchFamily="34" charset="-122"/>
+                <a:cs typeface="Open Sans" pitchFamily="34" charset="-120"/>
+              </a:rPr>
+              <a:t>2019-01-01 to 2022-12-31; daily calendar</a:t>
+            </a:r>
+            <a:endParaRPr lang="en-US" sz="1000" dirty="0"/>
+          </a:p>
+        </p:txBody>
+      </p:sp>
+      <p:sp>
+        <p:nvSpPr>
+          <p:cNvPr id="10" name="Shape 8"/>
+          <p:cNvSpPr/>
+          <p:nvPr/>
+        </p:nvSpPr>
+        <p:spPr>
+          <a:xfrm>
+            <a:off x="4370832" y="1755648"/>
+            <a:ext cx="3456432" cy="1234440"/>
+          </a:xfrm>
+          <a:prstGeom prst="roundRect">
+            <a:avLst>
+              <a:gd name="adj" fmla="val 5926"/>
+            </a:avLst>
+          </a:prstGeom>
+          <a:solidFill>
+            <a:srgbClr val="FFFFFF"/>
+          </a:solidFill>
+          <a:ln w="10160">
+            <a:solidFill>
+              <a:srgbClr val="DEE2E6"/>
+            </a:solidFill>
+            <a:prstDash val="solid"/>
+          </a:ln>
+        </p:spPr>
+      </p:sp>
+      <p:sp>
+        <p:nvSpPr>
+          <p:cNvPr id="11" name="Shape 9"/>
+          <p:cNvSpPr/>
+          <p:nvPr/>
+        </p:nvSpPr>
+        <p:spPr>
+          <a:xfrm>
+            <a:off x="4370832" y="1755648"/>
+            <a:ext cx="73152" cy="1234440"/>
+          </a:xfrm>
+          <a:prstGeom prst="rect">
+            <a:avLst/>
+          </a:prstGeom>
+          <a:solidFill>
+            <a:srgbClr val="30445C"/>
+          </a:solidFill>
+          <a:ln w="12700">
+            <a:solidFill>
+              <a:srgbClr val="30445C">
+                <a:alpha val="0"/>
+              </a:srgbClr>
+            </a:solidFill>
+            <a:prstDash val="solid"/>
+          </a:ln>
+        </p:spPr>
+      </p:sp>
+      <p:sp>
+        <p:nvSpPr>
+          <p:cNvPr id="12" name="Text 10"/>
+          <p:cNvSpPr/>
+          <p:nvPr/>
+        </p:nvSpPr>
+        <p:spPr>
+          <a:xfrm>
+            <a:off x="4572000" y="1901952"/>
+            <a:ext cx="3090672" cy="228600"/>
+          </a:xfrm>
+          <a:prstGeom prst="rect">
+            <a:avLst/>
+          </a:prstGeom>
+          <a:noFill/>
+          <a:ln/>
+        </p:spPr>
+        <p:txBody>
+          <a:bodyPr wrap="square" lIns="0" tIns="0" rIns="0" bIns="0" rtlCol="0" anchor="ctr">
+            <a:normAutofit/>
+          </a:bodyPr>
+          <a:lstStyle/>
+          <a:p>
+            <a:pPr indent="0" marL="0">
+              <a:buNone/>
+            </a:pPr>
+            <a:r>
+              <a:rPr lang="en-US" sz="900" b="1" dirty="0">
+                <a:solidFill>
+                  <a:srgbClr val="6C757D"/>
+                </a:solidFill>
+                <a:latin typeface="Open Sans" pitchFamily="34" charset="0"/>
+                <a:ea typeface="Open Sans" pitchFamily="34" charset="-122"/>
+                <a:cs typeface="Open Sans" pitchFamily="34" charset="-120"/>
+              </a:rPr>
+              <a:t>DIM_PRODUCT</a:t>
+            </a:r>
+            <a:endParaRPr lang="en-US" sz="900" dirty="0"/>
+          </a:p>
+        </p:txBody>
+      </p:sp>
+      <p:sp>
+        <p:nvSpPr>
+          <p:cNvPr id="13" name="Text 11"/>
+          <p:cNvSpPr/>
+          <p:nvPr/>
+        </p:nvSpPr>
+        <p:spPr>
+          <a:xfrm>
+            <a:off x="4572000" y="2240280"/>
+            <a:ext cx="3090672" cy="438912"/>
+          </a:xfrm>
+          <a:prstGeom prst="rect">
+            <a:avLst/>
+          </a:prstGeom>
+          <a:noFill/>
+          <a:ln/>
+        </p:spPr>
+        <p:txBody>
+          <a:bodyPr wrap="square" lIns="0" tIns="0" rIns="0" bIns="0" rtlCol="0" anchor="ctr">
+            <a:normAutofit/>
+          </a:bodyPr>
+          <a:lstStyle/>
+          <a:p>
+            <a:pPr indent="0" marL="0">
+              <a:buNone/>
+            </a:pPr>
+            <a:r>
+              <a:rPr lang="en-US" sz="2300" b="1" dirty="0">
+                <a:solidFill>
+                  <a:srgbClr val="212529"/>
+                </a:solidFill>
+                <a:latin typeface="Open Sans" pitchFamily="34" charset="0"/>
+                <a:ea typeface="Open Sans" pitchFamily="34" charset="-122"/>
+                <a:cs typeface="Open Sans" pitchFamily="34" charset="-120"/>
+              </a:rPr>
+              <a:t>17 rows</a:t>
+            </a:r>
+            <a:endParaRPr lang="en-US" sz="2300" dirty="0"/>
+          </a:p>
+        </p:txBody>
+      </p:sp>
+      <p:sp>
+        <p:nvSpPr>
+          <p:cNvPr id="14" name="Text 12"/>
+          <p:cNvSpPr/>
+          <p:nvPr/>
+        </p:nvSpPr>
+        <p:spPr>
+          <a:xfrm>
+            <a:off x="4572000" y="2734056"/>
+            <a:ext cx="3090672" cy="155448"/>
+          </a:xfrm>
+          <a:prstGeom prst="rect">
+            <a:avLst/>
+          </a:prstGeom>
+          <a:noFill/>
+          <a:ln/>
+        </p:spPr>
+        <p:txBody>
+          <a:bodyPr wrap="square" lIns="0" tIns="0" rIns="0" bIns="0" rtlCol="0" anchor="t">
+            <a:normAutofit/>
+          </a:bodyPr>
+          <a:lstStyle/>
+          <a:p>
+            <a:pPr indent="0" marL="0">
+              <a:buNone/>
+            </a:pPr>
+            <a:r>
+              <a:rPr lang="en-US" sz="1000" dirty="0">
+                <a:solidFill>
+                  <a:srgbClr val="6C757D"/>
+                </a:solidFill>
+                <a:latin typeface="Open Sans" pitchFamily="34" charset="0"/>
+                <a:ea typeface="Open Sans" pitchFamily="34" charset="-122"/>
+                <a:cs typeface="Open Sans" pitchFamily="34" charset="-120"/>
+              </a:rPr>
+              <a:t>16 known + Unknown</a:t>
+            </a:r>
+            <a:endParaRPr lang="en-US" sz="1000" dirty="0"/>
+          </a:p>
+        </p:txBody>
+      </p:sp>
+      <p:sp>
+        <p:nvSpPr>
+          <p:cNvPr id="15" name="Shape 13"/>
+          <p:cNvSpPr/>
+          <p:nvPr/>
+        </p:nvSpPr>
+        <p:spPr>
+          <a:xfrm>
+            <a:off x="8028432" y="1755648"/>
+            <a:ext cx="3456432" cy="1234440"/>
+          </a:xfrm>
+          <a:prstGeom prst="roundRect">
+            <a:avLst>
+              <a:gd name="adj" fmla="val 5926"/>
+            </a:avLst>
+          </a:prstGeom>
+          <a:solidFill>
+            <a:srgbClr val="FFFFFF"/>
+          </a:solidFill>
+          <a:ln w="10160">
+            <a:solidFill>
+              <a:srgbClr val="DEE2E6"/>
+            </a:solidFill>
+            <a:prstDash val="solid"/>
+          </a:ln>
+        </p:spPr>
+      </p:sp>
+      <p:sp>
+        <p:nvSpPr>
+          <p:cNvPr id="16" name="Shape 14"/>
+          <p:cNvSpPr/>
+          <p:nvPr/>
+        </p:nvSpPr>
+        <p:spPr>
+          <a:xfrm>
+            <a:off x="8028432" y="1755648"/>
+            <a:ext cx="73152" cy="1234440"/>
+          </a:xfrm>
+          <a:prstGeom prst="rect">
+            <a:avLst/>
+          </a:prstGeom>
+          <a:solidFill>
+            <a:srgbClr val="30445C"/>
+          </a:solidFill>
+          <a:ln w="12700">
+            <a:solidFill>
+              <a:srgbClr val="30445C">
+                <a:alpha val="0"/>
+              </a:srgbClr>
+            </a:solidFill>
+            <a:prstDash val="solid"/>
+          </a:ln>
+        </p:spPr>
+      </p:sp>
+      <p:sp>
+        <p:nvSpPr>
+          <p:cNvPr id="17" name="Text 15"/>
+          <p:cNvSpPr/>
+          <p:nvPr/>
+        </p:nvSpPr>
+        <p:spPr>
+          <a:xfrm>
+            <a:off x="8229600" y="1901952"/>
+            <a:ext cx="3090672" cy="228600"/>
+          </a:xfrm>
+          <a:prstGeom prst="rect">
+            <a:avLst/>
+          </a:prstGeom>
+          <a:noFill/>
+          <a:ln/>
+        </p:spPr>
+        <p:txBody>
+          <a:bodyPr wrap="square" lIns="0" tIns="0" rIns="0" bIns="0" rtlCol="0" anchor="ctr">
+            <a:normAutofit/>
+          </a:bodyPr>
+          <a:lstStyle/>
+          <a:p>
+            <a:pPr indent="0" marL="0">
+              <a:buNone/>
+            </a:pPr>
+            <a:r>
+              <a:rPr lang="en-US" sz="900" b="1" dirty="0">
+                <a:solidFill>
+                  <a:srgbClr val="6C757D"/>
+                </a:solidFill>
+                <a:latin typeface="Open Sans" pitchFamily="34" charset="0"/>
+                <a:ea typeface="Open Sans" pitchFamily="34" charset="-122"/>
+                <a:cs typeface="Open Sans" pitchFamily="34" charset="-120"/>
+              </a:rPr>
+              <a:t>DIM_STORE</a:t>
+            </a:r>
+            <a:endParaRPr lang="en-US" sz="900" dirty="0"/>
+          </a:p>
+        </p:txBody>
+      </p:sp>
+      <p:sp>
+        <p:nvSpPr>
+          <p:cNvPr id="18" name="Text 16"/>
+          <p:cNvSpPr/>
+          <p:nvPr/>
+        </p:nvSpPr>
+        <p:spPr>
+          <a:xfrm>
+            <a:off x="8229600" y="2240280"/>
+            <a:ext cx="3090672" cy="438912"/>
+          </a:xfrm>
+          <a:prstGeom prst="rect">
+            <a:avLst/>
+          </a:prstGeom>
+          <a:noFill/>
+          <a:ln/>
+        </p:spPr>
+        <p:txBody>
+          <a:bodyPr wrap="square" lIns="0" tIns="0" rIns="0" bIns="0" rtlCol="0" anchor="ctr">
+            <a:normAutofit/>
+          </a:bodyPr>
+          <a:lstStyle/>
+          <a:p>
+            <a:pPr indent="0" marL="0">
+              <a:buNone/>
+            </a:pPr>
+            <a:r>
+              <a:rPr lang="en-US" sz="2300" b="1" dirty="0">
+                <a:solidFill>
+                  <a:srgbClr val="212529"/>
+                </a:solidFill>
+                <a:latin typeface="Open Sans" pitchFamily="34" charset="0"/>
+                <a:ea typeface="Open Sans" pitchFamily="34" charset="-122"/>
+                <a:cs typeface="Open Sans" pitchFamily="34" charset="-120"/>
+              </a:rPr>
+              <a:t>288 rows</a:t>
+            </a:r>
+            <a:endParaRPr lang="en-US" sz="2300" dirty="0"/>
+          </a:p>
+        </p:txBody>
+      </p:sp>
+      <p:sp>
+        <p:nvSpPr>
+          <p:cNvPr id="19" name="Text 17"/>
+          <p:cNvSpPr/>
+          <p:nvPr/>
+        </p:nvSpPr>
+        <p:spPr>
+          <a:xfrm>
+            <a:off x="8229600" y="2734056"/>
+            <a:ext cx="3090672" cy="155448"/>
+          </a:xfrm>
+          <a:prstGeom prst="rect">
+            <a:avLst/>
+          </a:prstGeom>
+          <a:noFill/>
+          <a:ln/>
+        </p:spPr>
+        <p:txBody>
+          <a:bodyPr wrap="square" lIns="0" tIns="0" rIns="0" bIns="0" rtlCol="0" anchor="t">
+            <a:normAutofit/>
+          </a:bodyPr>
+          <a:lstStyle/>
+          <a:p>
+            <a:pPr indent="0" marL="0">
+              <a:buNone/>
+            </a:pPr>
+            <a:r>
+              <a:rPr lang="en-US" sz="1000" dirty="0">
+                <a:solidFill>
+                  <a:srgbClr val="6C757D"/>
+                </a:solidFill>
+                <a:latin typeface="Open Sans" pitchFamily="34" charset="0"/>
+                <a:ea typeface="Open Sans" pitchFamily="34" charset="-122"/>
+                <a:cs typeface="Open Sans" pitchFamily="34" charset="-120"/>
+              </a:rPr>
+              <a:t>287 known + Unknown</a:t>
+            </a:r>
+            <a:endParaRPr lang="en-US" sz="1000" dirty="0"/>
+          </a:p>
+        </p:txBody>
+      </p:sp>
+      <p:sp>
+        <p:nvSpPr>
+          <p:cNvPr id="20" name="Shape 18"/>
+          <p:cNvSpPr/>
+          <p:nvPr/>
+        </p:nvSpPr>
+        <p:spPr>
+          <a:xfrm>
+            <a:off x="3767328" y="3346704"/>
+            <a:ext cx="4663440" cy="786384"/>
+          </a:xfrm>
+          <a:prstGeom prst="roundRect">
+            <a:avLst>
+              <a:gd name="adj" fmla="val 8140"/>
+            </a:avLst>
+          </a:prstGeom>
+          <a:solidFill>
+            <a:srgbClr val="212529"/>
+          </a:solidFill>
+          <a:ln w="12700">
+            <a:solidFill>
+              <a:srgbClr val="212529">
+                <a:alpha val="0"/>
+              </a:srgbClr>
+            </a:solidFill>
+            <a:prstDash val="solid"/>
+          </a:ln>
+        </p:spPr>
+      </p:sp>
+      <p:sp>
+        <p:nvSpPr>
+          <p:cNvPr id="21" name="Text 19"/>
+          <p:cNvSpPr/>
+          <p:nvPr/>
+        </p:nvSpPr>
+        <p:spPr>
+          <a:xfrm>
+            <a:off x="3977640" y="3566160"/>
+            <a:ext cx="4251960" cy="310896"/>
+          </a:xfrm>
+          <a:prstGeom prst="rect">
+            <a:avLst/>
+          </a:prstGeom>
+          <a:noFill/>
+          <a:ln/>
+        </p:spPr>
+        <p:txBody>
+          <a:bodyPr wrap="square" lIns="0" tIns="0" rIns="0" bIns="0" rtlCol="0" anchor="ctr">
+            <a:normAutofit/>
+          </a:bodyPr>
+          <a:lstStyle/>
+          <a:p>
+            <a:pPr algn="ctr" indent="0" marL="0">
+              <a:buNone/>
+            </a:pPr>
+            <a:r>
+              <a:rPr lang="en-US" sz="1700" b="1" dirty="0">
+                <a:solidFill>
+                  <a:srgbClr val="FFFFFF"/>
+                </a:solidFill>
+                <a:latin typeface="Open Sans" pitchFamily="34" charset="0"/>
+                <a:ea typeface="Open Sans" pitchFamily="34" charset="-122"/>
+                <a:cs typeface="Open Sans" pitchFamily="34" charset="-120"/>
+              </a:rPr>
+              <a:t>FCT_SALES  |  499,665 rows</a:t>
+            </a:r>
+            <a:endParaRPr lang="en-US" sz="1700" dirty="0"/>
+          </a:p>
+        </p:txBody>
+      </p:sp>
+      <p:sp>
+        <p:nvSpPr>
+          <p:cNvPr id="22" name="Text 20"/>
+          <p:cNvSpPr/>
+          <p:nvPr/>
+        </p:nvSpPr>
+        <p:spPr>
+          <a:xfrm>
+            <a:off x="877824" y="4498848"/>
+            <a:ext cx="3310128" cy="274320"/>
+          </a:xfrm>
+          <a:prstGeom prst="rect">
+            <a:avLst/>
+          </a:prstGeom>
+          <a:noFill/>
+          <a:ln/>
+        </p:spPr>
+        <p:txBody>
+          <a:bodyPr wrap="square" lIns="0" tIns="0" rIns="0" bIns="0" rtlCol="0" anchor="ctr">
+            <a:normAutofit/>
+          </a:bodyPr>
+          <a:lstStyle/>
+          <a:p>
+            <a:pPr indent="0" marL="0">
+              <a:buNone/>
+            </a:pPr>
+            <a:r>
+              <a:rPr lang="en-US" sz="1100" b="1" dirty="0">
+                <a:solidFill>
+                  <a:srgbClr val="212529"/>
+                </a:solidFill>
+                <a:latin typeface="Open Sans" pitchFamily="34" charset="0"/>
+                <a:ea typeface="Open Sans" pitchFamily="34" charset="-122"/>
+                <a:cs typeface="Open Sans" pitchFamily="34" charset="-120"/>
+              </a:rPr>
+              <a:t>Category  -&gt;  product ID / name</a:t>
+            </a:r>
+            <a:endParaRPr lang="en-US" sz="1100" dirty="0"/>
+          </a:p>
+        </p:txBody>
+      </p:sp>
+      <p:sp>
+        <p:nvSpPr>
+          <p:cNvPr id="23" name="Text 21"/>
+          <p:cNvSpPr/>
+          <p:nvPr/>
+        </p:nvSpPr>
+        <p:spPr>
+          <a:xfrm>
+            <a:off x="877824" y="4846320"/>
+            <a:ext cx="3383280" cy="603504"/>
+          </a:xfrm>
+          <a:prstGeom prst="rect">
+            <a:avLst/>
+          </a:prstGeom>
+          <a:noFill/>
+          <a:ln/>
+        </p:spPr>
+        <p:txBody>
+          <a:bodyPr wrap="square" lIns="0" tIns="0" rIns="0" bIns="0" rtlCol="0" anchor="t">
+            <a:normAutofit/>
+          </a:bodyPr>
+          <a:lstStyle/>
+          <a:p>
+            <a:pPr indent="0" marL="0">
+              <a:buNone/>
+            </a:pPr>
+            <a:r>
+              <a:rPr lang="en-US" sz="1000" dirty="0">
+                <a:solidFill>
+                  <a:srgbClr val="6C757D"/>
+                </a:solidFill>
+                <a:latin typeface="Open Sans" pitchFamily="34" charset="0"/>
+                <a:ea typeface="Open Sans" pitchFamily="34" charset="-122"/>
+                <a:cs typeface="Open Sans" pitchFamily="34" charset="-120"/>
+              </a:rPr>
+              <a:t>Pack size is a packaging attribute (1 or 2), not a hierarchy level. 6 categories in source.</a:t>
+            </a:r>
+            <a:endParaRPr lang="en-US" sz="1000" dirty="0"/>
+          </a:p>
+        </p:txBody>
+      </p:sp>
+      <p:sp>
+        <p:nvSpPr>
+          <p:cNvPr id="24" name="Text 22"/>
+          <p:cNvSpPr/>
+          <p:nvPr/>
+        </p:nvSpPr>
+        <p:spPr>
+          <a:xfrm>
+            <a:off x="4443984" y="4498848"/>
+            <a:ext cx="3310128" cy="274320"/>
+          </a:xfrm>
+          <a:prstGeom prst="rect">
+            <a:avLst/>
+          </a:prstGeom>
+          <a:noFill/>
+          <a:ln/>
+        </p:spPr>
+        <p:txBody>
+          <a:bodyPr wrap="square" lIns="0" tIns="0" rIns="0" bIns="0" rtlCol="0" anchor="ctr">
+            <a:normAutofit/>
+          </a:bodyPr>
+          <a:lstStyle/>
+          <a:p>
+            <a:pPr indent="0" marL="0">
+              <a:buNone/>
+            </a:pPr>
+            <a:r>
+              <a:rPr lang="en-US" sz="1100" b="1" dirty="0">
+                <a:solidFill>
+                  <a:srgbClr val="212529"/>
+                </a:solidFill>
+                <a:latin typeface="Open Sans" pitchFamily="34" charset="0"/>
+                <a:ea typeface="Open Sans" pitchFamily="34" charset="-122"/>
+                <a:cs typeface="Open Sans" pitchFamily="34" charset="-120"/>
+              </a:rPr>
+              <a:t>Region  -&gt;  state  -&gt;  store ID</a:t>
+            </a:r>
+            <a:endParaRPr lang="en-US" sz="1100" dirty="0"/>
+          </a:p>
+        </p:txBody>
+      </p:sp>
+      <p:sp>
+        <p:nvSpPr>
+          <p:cNvPr id="25" name="Text 23"/>
+          <p:cNvSpPr/>
+          <p:nvPr/>
+        </p:nvSpPr>
+        <p:spPr>
+          <a:xfrm>
+            <a:off x="4443984" y="4846320"/>
+            <a:ext cx="3310128" cy="457200"/>
+          </a:xfrm>
+          <a:prstGeom prst="rect">
+            <a:avLst/>
+          </a:prstGeom>
+          <a:noFill/>
+          <a:ln/>
+        </p:spPr>
+        <p:txBody>
+          <a:bodyPr wrap="square" lIns="0" tIns="0" rIns="0" bIns="0" rtlCol="0" anchor="t">
+            <a:normAutofit/>
+          </a:bodyPr>
+          <a:lstStyle/>
+          <a:p>
+            <a:pPr indent="0" marL="0">
+              <a:buNone/>
+            </a:pPr>
+            <a:r>
+              <a:rPr lang="en-US" sz="1000" dirty="0">
+                <a:solidFill>
+                  <a:srgbClr val="6C757D"/>
+                </a:solidFill>
+                <a:latin typeface="Open Sans" pitchFamily="34" charset="0"/>
+                <a:ea typeface="Open Sans" pitchFamily="34" charset="-122"/>
+                <a:cs typeface="Open Sans" pitchFamily="34" charset="-120"/>
+              </a:rPr>
+              <a:t>Store type is a slice. Store name alone is not unique.</a:t>
+            </a:r>
+            <a:endParaRPr lang="en-US" sz="1000" dirty="0"/>
+          </a:p>
+        </p:txBody>
+      </p:sp>
+      <p:sp>
+        <p:nvSpPr>
+          <p:cNvPr id="26" name="Text 24"/>
+          <p:cNvSpPr/>
+          <p:nvPr/>
+        </p:nvSpPr>
+        <p:spPr>
+          <a:xfrm>
+            <a:off x="8028432" y="4498848"/>
+            <a:ext cx="3310128" cy="274320"/>
+          </a:xfrm>
+          <a:prstGeom prst="rect">
+            <a:avLst/>
+          </a:prstGeom>
+          <a:noFill/>
+          <a:ln/>
+        </p:spPr>
+        <p:txBody>
+          <a:bodyPr wrap="square" lIns="0" tIns="0" rIns="0" bIns="0" rtlCol="0" anchor="ctr">
+            <a:normAutofit/>
+          </a:bodyPr>
+          <a:lstStyle/>
+          <a:p>
+            <a:pPr indent="0" marL="0">
+              <a:buNone/>
+            </a:pPr>
+            <a:r>
+              <a:rPr lang="en-US" sz="1100" b="1" dirty="0">
+                <a:solidFill>
+                  <a:srgbClr val="212529"/>
+                </a:solidFill>
+                <a:latin typeface="Open Sans" pitchFamily="34" charset="0"/>
+                <a:ea typeface="Open Sans" pitchFamily="34" charset="-122"/>
+                <a:cs typeface="Open Sans" pitchFamily="34" charset="-120"/>
+              </a:rPr>
+              <a:t>Year / quarter / month / day</a:t>
+            </a:r>
+            <a:endParaRPr lang="en-US" sz="1100" dirty="0"/>
+          </a:p>
+        </p:txBody>
+      </p:sp>
+      <p:sp>
+        <p:nvSpPr>
+          <p:cNvPr id="27" name="Text 25"/>
+          <p:cNvSpPr/>
+          <p:nvPr/>
+        </p:nvSpPr>
+        <p:spPr>
+          <a:xfrm>
+            <a:off x="8028432" y="4846320"/>
+            <a:ext cx="3383280" cy="594360"/>
+          </a:xfrm>
+          <a:prstGeom prst="rect">
+            <a:avLst/>
+          </a:prstGeom>
+          <a:noFill/>
+          <a:ln/>
+        </p:spPr>
+        <p:txBody>
+          <a:bodyPr wrap="square" lIns="0" tIns="0" rIns="0" bIns="0" rtlCol="0" anchor="t">
+            <a:normAutofit/>
+          </a:bodyPr>
+          <a:lstStyle/>
+          <a:p>
+            <a:pPr indent="0" marL="0">
+              <a:buNone/>
+            </a:pPr>
+            <a:r>
+              <a:rPr lang="en-US" sz="1000" dirty="0">
+                <a:solidFill>
+                  <a:srgbClr val="6C757D"/>
+                </a:solidFill>
+                <a:latin typeface="Open Sans" pitchFamily="34" charset="0"/>
+                <a:ea typeface="Open Sans" pitchFamily="34" charset="-122"/>
+                <a:cs typeface="Open Sans" pitchFamily="34" charset="-120"/>
+              </a:rPr>
+              <a:t>All 499,665 events happen on 48 first-of-month dates; the calendar still provides 1,461 days.</a:t>
+            </a:r>
+            <a:endParaRPr lang="en-US" sz="1000" dirty="0"/>
+          </a:p>
+        </p:txBody>
+      </p:sp>
+      <p:sp>
+        <p:nvSpPr>
+          <p:cNvPr id="28" name="Text 26"/>
+          <p:cNvSpPr/>
+          <p:nvPr/>
+        </p:nvSpPr>
+        <p:spPr>
+          <a:xfrm>
+            <a:off x="896112" y="5760720"/>
+            <a:ext cx="10515600" cy="274320"/>
+          </a:xfrm>
+          <a:prstGeom prst="rect">
+            <a:avLst/>
+          </a:prstGeom>
+          <a:noFill/>
+          <a:ln/>
+        </p:spPr>
+        <p:txBody>
+          <a:bodyPr wrap="square" lIns="0" tIns="0" rIns="0" bIns="0" rtlCol="0" anchor="ctr">
+            <a:normAutofit/>
+          </a:bodyPr>
+          <a:lstStyle/>
+          <a:p>
+            <a:pPr indent="0" marL="0">
+              <a:buNone/>
+            </a:pPr>
+            <a:r>
+              <a:rPr lang="en-US" sz="1000" b="1" dirty="0">
+                <a:solidFill>
+                  <a:srgbClr val="6E9117"/>
+                </a:solidFill>
+                <a:latin typeface="Open Sans" pitchFamily="34" charset="0"/>
+                <a:ea typeface="Open Sans" pitchFamily="34" charset="-122"/>
+                <a:cs typeface="Open Sans" pitchFamily="34" charset="-120"/>
+              </a:rPr>
+              <a:t>Annual/monthly and product/store/region reports are aggregate marts, not additional fact tables.</a:t>
+            </a:r>
+            <a:endParaRPr lang="en-US" sz="1000" dirty="0"/>
+          </a:p>
+        </p:txBody>
+      </p:sp>
+      <p:sp>
+        <p:nvSpPr>
+          <p:cNvPr id="25" name="Slide Number Placeholder 0"/>
+          <p:cNvSpPr>
+            <a:spLocks noGrp="1"/>
+          </p:cNvSpPr>
+          <p:nvPr>
+            <p:ph type="sldNum" sz="quarter" idx="4294967295"/>
+          </p:nvPr>
+        </p:nvSpPr>
+        <p:spPr>
+          <a:xfrm>
+            <a:off x="11201400" y="6473952"/>
+            <a:ext cx="800000" cy="300000"/>
+          </a:xfrm>
+          <a:prstGeom prst="rect">
+            <a:avLst/>
+          </a:prstGeom>
+          <a:extLst>
+            <a:ext uri="{C572A759-6A51-4108-AA02-DFA0A04FC94B}">
+              <ma14:wrappingTextBoxFlag xmlns:ma14="http://schemas.microsoft.com/office/mac/drawingml/2011/main" val="0"/>
+            </a:ext>
+          </a:extLst>
+        </p:spPr>
+        <p:txBody>
+          <a:bodyPr/>
+          <a:lstStyle>
+            <a:lvl1pPr>
+              <a:defRPr sz="900">
+                <a:solidFill>
+                  <a:srgbClr val="6C757D"/>
+                </a:solidFill>
+                <a:latin typeface="Open Sans"/>
+                <a:ea typeface="Open Sans"/>
+                <a:cs typeface="Open Sans"/>
+              </a:defRPr>
+            </a:lvl1pPr>
+          </a:lstStyle>
+          <a:p>
+            <a:pPr algn="l"/>
+            <a:fld id="{F7021451-1387-4CA6-816F-3879F97B5CBC}" type="slidenum">
+              <a:rPr b="0" lang="en-US"/>
+              <a:t>11</a:t>
+            </a:fld>
+            <a:endParaRPr lang="en-US"/>
+          </a:p>
+        </p:txBody>
+      </p:sp>
+    </p:spTree>
+  </p:cSld>
+  <p:clrMapOvr>
+    <a:masterClrMapping/>
+  </p:clrMapOvr>
+</p:sld>
+</file>
+
+<file path=ppt/slides/slide12.xml><?xml version="1.0" encoding="utf-8"?>
+<p:sld xmlns:a="http://schemas.openxmlformats.org/drawingml/2006/main" xmlns:r="http://schemas.openxmlformats.org/officeDocument/2006/relationships" xmlns:p="http://schemas.openxmlformats.org/presentationml/2006/main">
+  <p:cSld name="Slide 12">
+    <p:spTree>
+      <p:nvGrpSpPr>
+        <p:cNvPr id="1" name=""/>
+        <p:cNvGrpSpPr/>
+        <p:nvPr/>
+      </p:nvGrpSpPr>
+      <p:grpSpPr>
+        <a:xfrm>
+          <a:off x="0" y="0"/>
+          <a:ext cx="0" cy="0"/>
+          <a:chOff x="0" y="0"/>
+          <a:chExt cx="0" cy="0"/>
+        </a:xfrm>
+      </p:grpSpPr>
+      <p:sp>
+        <p:nvSpPr>
+          <p:cNvPr id="2" name="Text 0"/>
+          <p:cNvSpPr/>
+          <p:nvPr/>
+        </p:nvSpPr>
+        <p:spPr>
+          <a:xfrm>
+            <a:off x="566928" y="384048"/>
+            <a:ext cx="10789920" cy="219456"/>
+          </a:xfrm>
+          <a:prstGeom prst="rect">
+            <a:avLst/>
+          </a:prstGeom>
+          <a:noFill/>
+          <a:ln/>
+        </p:spPr>
+        <p:txBody>
+          <a:bodyPr wrap="square" lIns="0" tIns="0" rIns="0" bIns="0" rtlCol="0" anchor="ctr">
+            <a:normAutofit/>
+          </a:bodyPr>
+          <a:lstStyle/>
+          <a:p>
+            <a:pPr indent="0" marL="0">
+              <a:buNone/>
+            </a:pPr>
+            <a:r>
+              <a:rPr lang="en-US" sz="1000" b="1" spc="120" kern="0" dirty="0">
+                <a:solidFill>
+                  <a:srgbClr val="6E9117"/>
+                </a:solidFill>
+                <a:latin typeface="Open Sans" pitchFamily="34" charset="0"/>
+                <a:ea typeface="Open Sans" pitchFamily="34" charset="-122"/>
+                <a:cs typeface="Open Sans" pitchFamily="34" charset="-120"/>
+              </a:rPr>
+              <a:t>SHARED FORMULAE, SEPARATE VIEWS</a:t>
+            </a:r>
+            <a:endParaRPr lang="en-US" sz="1000" dirty="0"/>
+          </a:p>
+        </p:txBody>
+      </p:sp>
+      <p:sp>
+        <p:nvSpPr>
+          <p:cNvPr id="3" name="Text 1"/>
+          <p:cNvSpPr/>
+          <p:nvPr/>
+        </p:nvSpPr>
+        <p:spPr>
+          <a:xfrm>
+            <a:off x="566928" y="694944"/>
+            <a:ext cx="10972800" cy="475488"/>
+          </a:xfrm>
+          <a:prstGeom prst="rect">
+            <a:avLst/>
+          </a:prstGeom>
+          <a:noFill/>
+          <a:ln/>
+        </p:spPr>
+        <p:txBody>
+          <a:bodyPr wrap="square" lIns="0" tIns="0" rIns="0" bIns="0" rtlCol="0" anchor="ctr">
+            <a:normAutofit/>
+          </a:bodyPr>
+          <a:lstStyle/>
+          <a:p>
+            <a:pPr indent="0" marL="0">
+              <a:buNone/>
+            </a:pPr>
+            <a:r>
+              <a:rPr lang="en-US" sz="2500" b="1" dirty="0">
+                <a:solidFill>
+                  <a:srgbClr val="212529"/>
+                </a:solidFill>
+                <a:latin typeface="Open Sans" pitchFamily="34" charset="0"/>
+                <a:ea typeface="Open Sans" pitchFamily="34" charset="-122"/>
+                <a:cs typeface="Open Sans" pitchFamily="34" charset="-120"/>
+              </a:rPr>
+              <a:t>Teams get their own tabs; management gets one global truth</a:t>
+            </a:r>
+            <a:endParaRPr lang="en-US" sz="2500" dirty="0"/>
+          </a:p>
+        </p:txBody>
+      </p:sp>
+      <p:sp>
+        <p:nvSpPr>
+          <p:cNvPr id="4" name="Text 2"/>
+          <p:cNvSpPr/>
+          <p:nvPr/>
+        </p:nvSpPr>
+        <p:spPr>
+          <a:xfrm>
+            <a:off x="566928" y="1207008"/>
+            <a:ext cx="10972800" cy="292608"/>
+          </a:xfrm>
+          <a:prstGeom prst="rect">
+            <a:avLst/>
+          </a:prstGeom>
+          <a:noFill/>
+          <a:ln/>
+        </p:spPr>
+        <p:txBody>
+          <a:bodyPr wrap="square" lIns="0" tIns="0" rIns="0" bIns="0" rtlCol="0" anchor="ctr">
+            <a:normAutofit/>
+          </a:bodyPr>
+          <a:lstStyle/>
+          <a:p>
+            <a:pPr indent="0" marL="0">
+              <a:buNone/>
+            </a:pPr>
+            <a:r>
+              <a:rPr lang="en-US" sz="1100" dirty="0">
+                <a:solidFill>
+                  <a:srgbClr val="6C757D"/>
+                </a:solidFill>
+                <a:latin typeface="Open Sans" pitchFamily="34" charset="0"/>
+                <a:ea typeface="Open Sans" pitchFamily="34" charset="-122"/>
+                <a:cs typeface="Open Sans" pitchFamily="34" charset="-120"/>
+              </a:rPr>
+              <a:t>Filter by team in mart_team_kpi_scorecard. The global measures are repeated, never redefined.</a:t>
+            </a:r>
+            <a:endParaRPr lang="en-US" sz="1100" dirty="0"/>
+          </a:p>
+        </p:txBody>
+      </p:sp>
+      <p:sp>
+        <p:nvSpPr>
+          <p:cNvPr id="5" name="Shape 3"/>
+          <p:cNvSpPr/>
+          <p:nvPr/>
+        </p:nvSpPr>
+        <p:spPr>
+          <a:xfrm>
+            <a:off x="731520" y="1737360"/>
+            <a:ext cx="3401568" cy="1298448"/>
+          </a:xfrm>
+          <a:prstGeom prst="roundRect">
+            <a:avLst>
+              <a:gd name="adj" fmla="val 5634"/>
+            </a:avLst>
+          </a:prstGeom>
+          <a:solidFill>
+            <a:srgbClr val="FFFFFF"/>
+          </a:solidFill>
+          <a:ln w="10160">
+            <a:solidFill>
+              <a:srgbClr val="DEE2E6"/>
+            </a:solidFill>
+            <a:prstDash val="solid"/>
+          </a:ln>
+        </p:spPr>
+      </p:sp>
+      <p:sp>
+        <p:nvSpPr>
+          <p:cNvPr id="6" name="Shape 4"/>
+          <p:cNvSpPr/>
+          <p:nvPr/>
+        </p:nvSpPr>
+        <p:spPr>
+          <a:xfrm>
+            <a:off x="731520" y="1737360"/>
+            <a:ext cx="73152" cy="1298448"/>
+          </a:xfrm>
+          <a:prstGeom prst="rect">
+            <a:avLst/>
+          </a:prstGeom>
+          <a:solidFill>
+            <a:srgbClr val="95C11F"/>
+          </a:solidFill>
+          <a:ln w="12700">
+            <a:solidFill>
+              <a:srgbClr val="95C11F">
+                <a:alpha val="0"/>
+              </a:srgbClr>
+            </a:solidFill>
+            <a:prstDash val="solid"/>
+          </a:ln>
+        </p:spPr>
+      </p:sp>
+      <p:sp>
+        <p:nvSpPr>
+          <p:cNvPr id="7" name="Text 5"/>
+          <p:cNvSpPr/>
+          <p:nvPr/>
+        </p:nvSpPr>
+        <p:spPr>
+          <a:xfrm>
+            <a:off x="932688" y="1883664"/>
+            <a:ext cx="3035808" cy="228600"/>
+          </a:xfrm>
+          <a:prstGeom prst="rect">
+            <a:avLst/>
+          </a:prstGeom>
+          <a:noFill/>
+          <a:ln/>
+        </p:spPr>
+        <p:txBody>
+          <a:bodyPr wrap="square" lIns="0" tIns="0" rIns="0" bIns="0" rtlCol="0" anchor="ctr">
+            <a:normAutofit/>
+          </a:bodyPr>
+          <a:lstStyle/>
+          <a:p>
+            <a:pPr indent="0" marL="0">
+              <a:buNone/>
+            </a:pPr>
+            <a:r>
+              <a:rPr lang="en-US" sz="900" b="1" dirty="0">
+                <a:solidFill>
+                  <a:srgbClr val="6C757D"/>
+                </a:solidFill>
+                <a:latin typeface="Open Sans" pitchFamily="34" charset="0"/>
+                <a:ea typeface="Open Sans" pitchFamily="34" charset="-122"/>
+                <a:cs typeface="Open Sans" pitchFamily="34" charset="-120"/>
+              </a:rPr>
+              <a:t>PORTFOLIO NET SALES / SQFT</a:t>
+            </a:r>
+            <a:endParaRPr lang="en-US" sz="900" dirty="0"/>
+          </a:p>
+        </p:txBody>
+      </p:sp>
+      <p:sp>
+        <p:nvSpPr>
+          <p:cNvPr id="8" name="Text 6"/>
+          <p:cNvSpPr/>
+          <p:nvPr/>
+        </p:nvSpPr>
+        <p:spPr>
+          <a:xfrm>
+            <a:off x="932688" y="2221992"/>
+            <a:ext cx="3035808" cy="438912"/>
+          </a:xfrm>
+          <a:prstGeom prst="rect">
+            <a:avLst/>
+          </a:prstGeom>
+          <a:noFill/>
+          <a:ln/>
+        </p:spPr>
+        <p:txBody>
+          <a:bodyPr wrap="square" lIns="0" tIns="0" rIns="0" bIns="0" rtlCol="0" anchor="ctr">
+            <a:normAutofit/>
+          </a:bodyPr>
+          <a:lstStyle/>
+          <a:p>
+            <a:pPr indent="0" marL="0">
+              <a:buNone/>
+            </a:pPr>
+            <a:r>
+              <a:rPr lang="en-US" sz="2300" b="1" dirty="0">
+                <a:solidFill>
+                  <a:srgbClr val="212529"/>
+                </a:solidFill>
+                <a:latin typeface="Open Sans" pitchFamily="34" charset="0"/>
+                <a:ea typeface="Open Sans" pitchFamily="34" charset="-122"/>
+                <a:cs typeface="Open Sans" pitchFamily="34" charset="-120"/>
+              </a:rPr>
+              <a:t>$0.27</a:t>
+            </a:r>
+            <a:endParaRPr lang="en-US" sz="2300" dirty="0"/>
+          </a:p>
+        </p:txBody>
+      </p:sp>
+      <p:sp>
+        <p:nvSpPr>
+          <p:cNvPr id="9" name="Text 7"/>
+          <p:cNvSpPr/>
+          <p:nvPr/>
+        </p:nvSpPr>
+        <p:spPr>
+          <a:xfrm>
+            <a:off x="932688" y="2715768"/>
+            <a:ext cx="3035808" cy="219456"/>
+          </a:xfrm>
+          <a:prstGeom prst="rect">
+            <a:avLst/>
+          </a:prstGeom>
+          <a:noFill/>
+          <a:ln/>
+        </p:spPr>
+        <p:txBody>
+          <a:bodyPr wrap="square" lIns="0" tIns="0" rIns="0" bIns="0" rtlCol="0" anchor="t">
+            <a:normAutofit/>
+          </a:bodyPr>
+          <a:lstStyle/>
+          <a:p>
+            <a:pPr indent="0" marL="0">
+              <a:buNone/>
+            </a:pPr>
+            <a:r>
+              <a:rPr lang="en-US" sz="1000" dirty="0">
+                <a:solidFill>
+                  <a:srgbClr val="6C757D"/>
+                </a:solidFill>
+                <a:latin typeface="Open Sans" pitchFamily="34" charset="0"/>
+                <a:ea typeface="Open Sans" pitchFamily="34" charset="-122"/>
+                <a:cs typeface="Open Sans" pitchFamily="34" charset="-120"/>
+              </a:rPr>
+              <a:t>286/287 stores have positive reported area</a:t>
+            </a:r>
+            <a:endParaRPr lang="en-US" sz="1000" dirty="0"/>
+          </a:p>
+        </p:txBody>
+      </p:sp>
+      <p:sp>
+        <p:nvSpPr>
+          <p:cNvPr id="10" name="Shape 8"/>
+          <p:cNvSpPr/>
+          <p:nvPr/>
+        </p:nvSpPr>
+        <p:spPr>
+          <a:xfrm>
+            <a:off x="4389120" y="1737360"/>
+            <a:ext cx="3401568" cy="1298448"/>
+          </a:xfrm>
+          <a:prstGeom prst="roundRect">
+            <a:avLst>
+              <a:gd name="adj" fmla="val 5634"/>
+            </a:avLst>
+          </a:prstGeom>
+          <a:solidFill>
+            <a:srgbClr val="FFFFFF"/>
+          </a:solidFill>
+          <a:ln w="10160">
+            <a:solidFill>
+              <a:srgbClr val="DEE2E6"/>
+            </a:solidFill>
+            <a:prstDash val="solid"/>
+          </a:ln>
+        </p:spPr>
+      </p:sp>
+      <p:sp>
+        <p:nvSpPr>
+          <p:cNvPr id="11" name="Shape 9"/>
+          <p:cNvSpPr/>
+          <p:nvPr/>
+        </p:nvSpPr>
+        <p:spPr>
+          <a:xfrm>
+            <a:off x="4389120" y="1737360"/>
+            <a:ext cx="73152" cy="1298448"/>
+          </a:xfrm>
+          <a:prstGeom prst="rect">
+            <a:avLst/>
+          </a:prstGeom>
+          <a:solidFill>
+            <a:srgbClr val="30445C"/>
+          </a:solidFill>
+          <a:ln w="12700">
+            <a:solidFill>
+              <a:srgbClr val="30445C">
+                <a:alpha val="0"/>
+              </a:srgbClr>
+            </a:solidFill>
+            <a:prstDash val="solid"/>
+          </a:ln>
+        </p:spPr>
+      </p:sp>
+      <p:sp>
+        <p:nvSpPr>
+          <p:cNvPr id="12" name="Text 10"/>
+          <p:cNvSpPr/>
+          <p:nvPr/>
+        </p:nvSpPr>
+        <p:spPr>
+          <a:xfrm>
+            <a:off x="4590288" y="1883664"/>
+            <a:ext cx="3035808" cy="228600"/>
+          </a:xfrm>
+          <a:prstGeom prst="rect">
+            <a:avLst/>
+          </a:prstGeom>
+          <a:noFill/>
+          <a:ln/>
+        </p:spPr>
+        <p:txBody>
+          <a:bodyPr wrap="square" lIns="0" tIns="0" rIns="0" bIns="0" rtlCol="0" anchor="ctr">
+            <a:normAutofit/>
+          </a:bodyPr>
+          <a:lstStyle/>
+          <a:p>
+            <a:pPr indent="0" marL="0">
+              <a:buNone/>
+            </a:pPr>
+            <a:r>
+              <a:rPr lang="en-US" sz="900" b="1" dirty="0">
+                <a:solidFill>
+                  <a:srgbClr val="6C757D"/>
+                </a:solidFill>
+                <a:latin typeface="Open Sans" pitchFamily="34" charset="0"/>
+                <a:ea typeface="Open Sans" pitchFamily="34" charset="-122"/>
+                <a:cs typeface="Open Sans" pitchFamily="34" charset="-120"/>
+              </a:rPr>
+              <a:t>STANDARD COST / SQFT</a:t>
+            </a:r>
+            <a:endParaRPr lang="en-US" sz="900" dirty="0"/>
+          </a:p>
+        </p:txBody>
+      </p:sp>
+      <p:sp>
+        <p:nvSpPr>
+          <p:cNvPr id="13" name="Text 11"/>
+          <p:cNvSpPr/>
+          <p:nvPr/>
+        </p:nvSpPr>
+        <p:spPr>
+          <a:xfrm>
+            <a:off x="4590288" y="2221992"/>
+            <a:ext cx="3035808" cy="438912"/>
+          </a:xfrm>
+          <a:prstGeom prst="rect">
+            <a:avLst/>
+          </a:prstGeom>
+          <a:noFill/>
+          <a:ln/>
+        </p:spPr>
+        <p:txBody>
+          <a:bodyPr wrap="square" lIns="0" tIns="0" rIns="0" bIns="0" rtlCol="0" anchor="ctr">
+            <a:normAutofit/>
+          </a:bodyPr>
+          <a:lstStyle/>
+          <a:p>
+            <a:pPr indent="0" marL="0">
+              <a:buNone/>
+            </a:pPr>
+            <a:r>
+              <a:rPr lang="en-US" sz="2300" b="1" dirty="0">
+                <a:solidFill>
+                  <a:srgbClr val="212529"/>
+                </a:solidFill>
+                <a:latin typeface="Open Sans" pitchFamily="34" charset="0"/>
+                <a:ea typeface="Open Sans" pitchFamily="34" charset="-122"/>
+                <a:cs typeface="Open Sans" pitchFamily="34" charset="-120"/>
+              </a:rPr>
+              <a:t>$0.16</a:t>
+            </a:r>
+            <a:endParaRPr lang="en-US" sz="2300" dirty="0"/>
+          </a:p>
+        </p:txBody>
+      </p:sp>
+      <p:sp>
+        <p:nvSpPr>
+          <p:cNvPr id="14" name="Text 12"/>
+          <p:cNvSpPr/>
+          <p:nvPr/>
+        </p:nvSpPr>
+        <p:spPr>
+          <a:xfrm>
+            <a:off x="4590288" y="2715768"/>
+            <a:ext cx="3035808" cy="219456"/>
+          </a:xfrm>
+          <a:prstGeom prst="rect">
+            <a:avLst/>
+          </a:prstGeom>
+          <a:noFill/>
+          <a:ln/>
+        </p:spPr>
+        <p:txBody>
+          <a:bodyPr wrap="square" lIns="0" tIns="0" rIns="0" bIns="0" rtlCol="0" anchor="t">
+            <a:normAutofit/>
+          </a:bodyPr>
+          <a:lstStyle/>
+          <a:p>
+            <a:pPr indent="0" marL="0">
+              <a:buNone/>
+            </a:pPr>
+            <a:r>
+              <a:rPr lang="en-US" sz="1000" dirty="0">
+                <a:solidFill>
+                  <a:srgbClr val="6C757D"/>
+                </a:solidFill>
+                <a:latin typeface="Open Sans" pitchFamily="34" charset="0"/>
+                <a:ea typeface="Open Sans" pitchFamily="34" charset="-122"/>
+                <a:cs typeface="Open Sans" pitchFamily="34" charset="-120"/>
+              </a:rPr>
+              <a:t>Area-covered stores; standard basis</a:t>
+            </a:r>
+            <a:endParaRPr lang="en-US" sz="1000" dirty="0"/>
+          </a:p>
+        </p:txBody>
+      </p:sp>
+      <p:sp>
+        <p:nvSpPr>
+          <p:cNvPr id="15" name="Shape 13"/>
+          <p:cNvSpPr/>
+          <p:nvPr/>
+        </p:nvSpPr>
+        <p:spPr>
+          <a:xfrm>
+            <a:off x="8046720" y="1737360"/>
+            <a:ext cx="3401568" cy="1298448"/>
+          </a:xfrm>
+          <a:prstGeom prst="roundRect">
+            <a:avLst>
+              <a:gd name="adj" fmla="val 5634"/>
+            </a:avLst>
+          </a:prstGeom>
+          <a:solidFill>
+            <a:srgbClr val="FFFFFF"/>
+          </a:solidFill>
+          <a:ln w="10160">
+            <a:solidFill>
+              <a:srgbClr val="DEE2E6"/>
+            </a:solidFill>
+            <a:prstDash val="solid"/>
+          </a:ln>
+        </p:spPr>
+      </p:sp>
+      <p:sp>
+        <p:nvSpPr>
+          <p:cNvPr id="16" name="Shape 14"/>
+          <p:cNvSpPr/>
+          <p:nvPr/>
+        </p:nvSpPr>
+        <p:spPr>
+          <a:xfrm>
+            <a:off x="8046720" y="1737360"/>
+            <a:ext cx="73152" cy="1298448"/>
+          </a:xfrm>
+          <a:prstGeom prst="rect">
+            <a:avLst/>
+          </a:prstGeom>
+          <a:solidFill>
+            <a:srgbClr val="95C11F"/>
+          </a:solidFill>
+          <a:ln w="12700">
+            <a:solidFill>
+              <a:srgbClr val="95C11F">
+                <a:alpha val="0"/>
+              </a:srgbClr>
+            </a:solidFill>
+            <a:prstDash val="solid"/>
+          </a:ln>
+        </p:spPr>
+      </p:sp>
+      <p:sp>
+        <p:nvSpPr>
+          <p:cNvPr id="17" name="Text 15"/>
+          <p:cNvSpPr/>
+          <p:nvPr/>
+        </p:nvSpPr>
+        <p:spPr>
+          <a:xfrm>
+            <a:off x="8247888" y="1883664"/>
+            <a:ext cx="3035808" cy="228600"/>
+          </a:xfrm>
+          <a:prstGeom prst="rect">
+            <a:avLst/>
+          </a:prstGeom>
+          <a:noFill/>
+          <a:ln/>
+        </p:spPr>
+        <p:txBody>
+          <a:bodyPr wrap="square" lIns="0" tIns="0" rIns="0" bIns="0" rtlCol="0" anchor="ctr">
+            <a:normAutofit/>
+          </a:bodyPr>
+          <a:lstStyle/>
+          <a:p>
+            <a:pPr indent="0" marL="0">
+              <a:buNone/>
+            </a:pPr>
+            <a:r>
+              <a:rPr lang="en-US" sz="900" b="1" dirty="0">
+                <a:solidFill>
+                  <a:srgbClr val="6C757D"/>
+                </a:solidFill>
+                <a:latin typeface="Open Sans" pitchFamily="34" charset="0"/>
+                <a:ea typeface="Open Sans" pitchFamily="34" charset="-122"/>
+                <a:cs typeface="Open Sans" pitchFamily="34" charset="-120"/>
+              </a:rPr>
+              <a:t>GROSS PROFIT / SQFT</a:t>
+            </a:r>
+            <a:endParaRPr lang="en-US" sz="900" dirty="0"/>
+          </a:p>
+        </p:txBody>
+      </p:sp>
+      <p:sp>
+        <p:nvSpPr>
+          <p:cNvPr id="18" name="Text 16"/>
+          <p:cNvSpPr/>
+          <p:nvPr/>
+        </p:nvSpPr>
+        <p:spPr>
+          <a:xfrm>
+            <a:off x="8247888" y="2221992"/>
+            <a:ext cx="3035808" cy="438912"/>
+          </a:xfrm>
+          <a:prstGeom prst="rect">
+            <a:avLst/>
+          </a:prstGeom>
+          <a:noFill/>
+          <a:ln/>
+        </p:spPr>
+        <p:txBody>
+          <a:bodyPr wrap="square" lIns="0" tIns="0" rIns="0" bIns="0" rtlCol="0" anchor="ctr">
+            <a:normAutofit/>
+          </a:bodyPr>
+          <a:lstStyle/>
+          <a:p>
+            <a:pPr indent="0" marL="0">
+              <a:buNone/>
+            </a:pPr>
+            <a:r>
+              <a:rPr lang="en-US" sz="2300" b="1" dirty="0">
+                <a:solidFill>
+                  <a:srgbClr val="212529"/>
+                </a:solidFill>
+                <a:latin typeface="Open Sans" pitchFamily="34" charset="0"/>
+                <a:ea typeface="Open Sans" pitchFamily="34" charset="-122"/>
+                <a:cs typeface="Open Sans" pitchFamily="34" charset="-120"/>
+              </a:rPr>
+              <a:t>$0.11</a:t>
+            </a:r>
+            <a:endParaRPr lang="en-US" sz="2300" dirty="0"/>
+          </a:p>
+        </p:txBody>
+      </p:sp>
+      <p:sp>
+        <p:nvSpPr>
+          <p:cNvPr id="19" name="Text 17"/>
+          <p:cNvSpPr/>
+          <p:nvPr/>
+        </p:nvSpPr>
+        <p:spPr>
+          <a:xfrm>
+            <a:off x="8247888" y="2715768"/>
+            <a:ext cx="3035808" cy="219456"/>
+          </a:xfrm>
+          <a:prstGeom prst="rect">
+            <a:avLst/>
+          </a:prstGeom>
+          <a:noFill/>
+          <a:ln/>
+        </p:spPr>
+        <p:txBody>
+          <a:bodyPr wrap="square" lIns="0" tIns="0" rIns="0" bIns="0" rtlCol="0" anchor="t">
+            <a:normAutofit/>
+          </a:bodyPr>
+          <a:lstStyle/>
+          <a:p>
+            <a:pPr indent="0" marL="0">
+              <a:buNone/>
+            </a:pPr>
+            <a:r>
+              <a:rPr lang="en-US" sz="1000" dirty="0">
+                <a:solidFill>
+                  <a:srgbClr val="6C757D"/>
+                </a:solidFill>
+                <a:latin typeface="Open Sans" pitchFamily="34" charset="0"/>
+                <a:ea typeface="Open Sans" pitchFamily="34" charset="-122"/>
+                <a:cs typeface="Open Sans" pitchFamily="34" charset="-120"/>
+              </a:rPr>
+              <a:t>Sales/sqft minus standard COGS/sqft</a:t>
+            </a:r>
+            <a:endParaRPr lang="en-US" sz="1000" dirty="0"/>
+          </a:p>
+        </p:txBody>
+      </p:sp>
+      <p:sp>
+        <p:nvSpPr>
+          <p:cNvPr id="20" name="Text 18"/>
+          <p:cNvSpPr/>
+          <p:nvPr/>
+        </p:nvSpPr>
+        <p:spPr>
+          <a:xfrm>
+            <a:off x="896112" y="3383280"/>
+            <a:ext cx="2011680" cy="256032"/>
+          </a:xfrm>
+          <a:prstGeom prst="rect">
+            <a:avLst/>
+          </a:prstGeom>
+          <a:noFill/>
+          <a:ln/>
+        </p:spPr>
+        <p:txBody>
+          <a:bodyPr wrap="square" lIns="0" tIns="0" rIns="0" bIns="0" rtlCol="0" anchor="ctr">
+            <a:normAutofit/>
+          </a:bodyPr>
+          <a:lstStyle/>
+          <a:p>
+            <a:pPr indent="0" marL="0">
+              <a:buNone/>
+            </a:pPr>
+            <a:r>
+              <a:rPr lang="en-US" sz="1000" b="1" dirty="0">
+                <a:solidFill>
+                  <a:srgbClr val="6E9117"/>
+                </a:solidFill>
+                <a:latin typeface="Open Sans" pitchFamily="34" charset="0"/>
+                <a:ea typeface="Open Sans" pitchFamily="34" charset="-122"/>
+                <a:cs typeface="Open Sans" pitchFamily="34" charset="-120"/>
+              </a:rPr>
+              <a:t>CEO / Management</a:t>
+            </a:r>
+            <a:endParaRPr lang="en-US" sz="1000" dirty="0"/>
+          </a:p>
+        </p:txBody>
+      </p:sp>
+      <p:sp>
+        <p:nvSpPr>
+          <p:cNvPr id="21" name="Text 19"/>
+          <p:cNvSpPr/>
+          <p:nvPr/>
+        </p:nvSpPr>
+        <p:spPr>
+          <a:xfrm>
+            <a:off x="2953512" y="3383280"/>
+            <a:ext cx="3429000" cy="411480"/>
+          </a:xfrm>
+          <a:prstGeom prst="rect">
+            <a:avLst/>
+          </a:prstGeom>
+          <a:noFill/>
+          <a:ln/>
+        </p:spPr>
+        <p:txBody>
+          <a:bodyPr wrap="square" lIns="0" tIns="0" rIns="0" bIns="0" rtlCol="0" anchor="t">
+            <a:normAutofit/>
+          </a:bodyPr>
+          <a:lstStyle/>
+          <a:p>
+            <a:pPr indent="0" marL="0">
+              <a:buNone/>
+            </a:pPr>
+            <a:r>
+              <a:rPr lang="en-US" sz="900" dirty="0">
+                <a:solidFill>
+                  <a:srgbClr val="6C757D"/>
+                </a:solidFill>
+                <a:latin typeface="Open Sans" pitchFamily="34" charset="0"/>
+                <a:ea typeface="Open Sans" pitchFamily="34" charset="-122"/>
+                <a:cs typeface="Open Sans" pitchFamily="34" charset="-120"/>
+              </a:rPr>
+              <a:t>Net sales, gross profit, margin, YoY</a:t>
+            </a:r>
+            <a:endParaRPr lang="en-US" sz="900" dirty="0"/>
+          </a:p>
+        </p:txBody>
+      </p:sp>
+      <p:sp>
+        <p:nvSpPr>
+          <p:cNvPr id="22" name="Text 20"/>
+          <p:cNvSpPr/>
+          <p:nvPr/>
+        </p:nvSpPr>
+        <p:spPr>
+          <a:xfrm>
+            <a:off x="896112" y="4005072"/>
+            <a:ext cx="2011680" cy="256032"/>
+          </a:xfrm>
+          <a:prstGeom prst="rect">
+            <a:avLst/>
+          </a:prstGeom>
+          <a:noFill/>
+          <a:ln/>
+        </p:spPr>
+        <p:txBody>
+          <a:bodyPr wrap="square" lIns="0" tIns="0" rIns="0" bIns="0" rtlCol="0" anchor="ctr">
+            <a:normAutofit/>
+          </a:bodyPr>
+          <a:lstStyle/>
+          <a:p>
+            <a:pPr indent="0" marL="0">
+              <a:buNone/>
+            </a:pPr>
+            <a:r>
+              <a:rPr lang="en-US" sz="1000" b="1" dirty="0">
+                <a:solidFill>
+                  <a:srgbClr val="6E9117"/>
+                </a:solidFill>
+                <a:latin typeface="Open Sans" pitchFamily="34" charset="0"/>
+                <a:ea typeface="Open Sans" pitchFamily="34" charset="-122"/>
+                <a:cs typeface="Open Sans" pitchFamily="34" charset="-120"/>
+              </a:rPr>
+              <a:t>Finance</a:t>
+            </a:r>
+            <a:endParaRPr lang="en-US" sz="1000" dirty="0"/>
+          </a:p>
+        </p:txBody>
+      </p:sp>
+      <p:sp>
+        <p:nvSpPr>
+          <p:cNvPr id="23" name="Text 21"/>
+          <p:cNvSpPr/>
+          <p:nvPr/>
+        </p:nvSpPr>
+        <p:spPr>
+          <a:xfrm>
+            <a:off x="2953512" y="4005072"/>
+            <a:ext cx="3429000" cy="411480"/>
+          </a:xfrm>
+          <a:prstGeom prst="rect">
+            <a:avLst/>
+          </a:prstGeom>
+          <a:noFill/>
+          <a:ln/>
+        </p:spPr>
+        <p:txBody>
+          <a:bodyPr wrap="square" lIns="0" tIns="0" rIns="0" bIns="0" rtlCol="0" anchor="t">
+            <a:normAutofit/>
+          </a:bodyPr>
+          <a:lstStyle/>
+          <a:p>
+            <a:pPr indent="0" marL="0">
+              <a:buNone/>
+            </a:pPr>
+            <a:r>
+              <a:rPr lang="en-US" sz="900" dirty="0">
+                <a:solidFill>
+                  <a:srgbClr val="6C757D"/>
+                </a:solidFill>
+                <a:latin typeface="Open Sans" pitchFamily="34" charset="0"/>
+                <a:ea typeface="Open Sans" pitchFamily="34" charset="-122"/>
+                <a:cs typeface="Open Sans" pitchFamily="34" charset="-120"/>
+              </a:rPr>
+              <a:t>Standard vs landed GM; cost coverage; opex-period scenarios</a:t>
+            </a:r>
+            <a:endParaRPr lang="en-US" sz="900" dirty="0"/>
+          </a:p>
+        </p:txBody>
+      </p:sp>
+      <p:sp>
+        <p:nvSpPr>
+          <p:cNvPr id="24" name="Text 22"/>
+          <p:cNvSpPr/>
+          <p:nvPr/>
+        </p:nvSpPr>
+        <p:spPr>
+          <a:xfrm>
+            <a:off x="896112" y="4626864"/>
+            <a:ext cx="2011680" cy="256032"/>
+          </a:xfrm>
+          <a:prstGeom prst="rect">
+            <a:avLst/>
+          </a:prstGeom>
+          <a:noFill/>
+          <a:ln/>
+        </p:spPr>
+        <p:txBody>
+          <a:bodyPr wrap="square" lIns="0" tIns="0" rIns="0" bIns="0" rtlCol="0" anchor="ctr">
+            <a:normAutofit/>
+          </a:bodyPr>
+          <a:lstStyle/>
+          <a:p>
+            <a:pPr indent="0" marL="0">
+              <a:buNone/>
+            </a:pPr>
+            <a:r>
+              <a:rPr lang="en-US" sz="1000" b="1" dirty="0">
+                <a:solidFill>
+                  <a:srgbClr val="6E9117"/>
+                </a:solidFill>
+                <a:latin typeface="Open Sans" pitchFamily="34" charset="0"/>
+                <a:ea typeface="Open Sans" pitchFamily="34" charset="-122"/>
+                <a:cs typeface="Open Sans" pitchFamily="34" charset="-120"/>
+              </a:rPr>
+              <a:t>Merchandising</a:t>
+            </a:r>
+            <a:endParaRPr lang="en-US" sz="1000" dirty="0"/>
+          </a:p>
+        </p:txBody>
+      </p:sp>
+      <p:sp>
+        <p:nvSpPr>
+          <p:cNvPr id="25" name="Text 23"/>
+          <p:cNvSpPr/>
+          <p:nvPr/>
+        </p:nvSpPr>
+        <p:spPr>
+          <a:xfrm>
+            <a:off x="2953512" y="4626864"/>
+            <a:ext cx="3429000" cy="411480"/>
+          </a:xfrm>
+          <a:prstGeom prst="rect">
+            <a:avLst/>
+          </a:prstGeom>
+          <a:noFill/>
+          <a:ln/>
+        </p:spPr>
+        <p:txBody>
+          <a:bodyPr wrap="square" lIns="0" tIns="0" rIns="0" bIns="0" rtlCol="0" anchor="t">
+            <a:normAutofit/>
+          </a:bodyPr>
+          <a:lstStyle/>
+          <a:p>
+            <a:pPr indent="0" marL="0">
+              <a:buNone/>
+            </a:pPr>
+            <a:r>
+              <a:rPr lang="en-US" sz="900" dirty="0">
+                <a:solidFill>
+                  <a:srgbClr val="6C757D"/>
+                </a:solidFill>
+                <a:latin typeface="Open Sans" pitchFamily="34" charset="0"/>
+                <a:ea typeface="Open Sans" pitchFamily="34" charset="-122"/>
+                <a:cs typeface="Open Sans" pitchFamily="34" charset="-120"/>
+              </a:rPr>
+              <a:t>Category growth, gross profit, selling units, pack-equivalent scenario</a:t>
+            </a:r>
+            <a:endParaRPr lang="en-US" sz="900" dirty="0"/>
+          </a:p>
+        </p:txBody>
+      </p:sp>
+      <p:sp>
+        <p:nvSpPr>
+          <p:cNvPr id="26" name="Text 24"/>
+          <p:cNvSpPr/>
+          <p:nvPr/>
+        </p:nvSpPr>
+        <p:spPr>
+          <a:xfrm>
+            <a:off x="6519672" y="3383280"/>
+            <a:ext cx="2011680" cy="256032"/>
+          </a:xfrm>
+          <a:prstGeom prst="rect">
+            <a:avLst/>
+          </a:prstGeom>
+          <a:noFill/>
+          <a:ln/>
+        </p:spPr>
+        <p:txBody>
+          <a:bodyPr wrap="square" lIns="0" tIns="0" rIns="0" bIns="0" rtlCol="0" anchor="ctr">
+            <a:normAutofit/>
+          </a:bodyPr>
+          <a:lstStyle/>
+          <a:p>
+            <a:pPr indent="0" marL="0">
+              <a:buNone/>
+            </a:pPr>
+            <a:r>
+              <a:rPr lang="en-US" sz="1000" b="1" dirty="0">
+                <a:solidFill>
+                  <a:srgbClr val="6E9117"/>
+                </a:solidFill>
+                <a:latin typeface="Open Sans" pitchFamily="34" charset="0"/>
+                <a:ea typeface="Open Sans" pitchFamily="34" charset="-122"/>
+                <a:cs typeface="Open Sans" pitchFamily="34" charset="-120"/>
+              </a:rPr>
+              <a:t>Store Operations</a:t>
+            </a:r>
+            <a:endParaRPr lang="en-US" sz="1000" dirty="0"/>
+          </a:p>
+        </p:txBody>
+      </p:sp>
+      <p:sp>
+        <p:nvSpPr>
+          <p:cNvPr id="27" name="Text 25"/>
+          <p:cNvSpPr/>
+          <p:nvPr/>
+        </p:nvSpPr>
+        <p:spPr>
+          <a:xfrm>
+            <a:off x="8577072" y="3383280"/>
+            <a:ext cx="3429000" cy="411480"/>
+          </a:xfrm>
+          <a:prstGeom prst="rect">
+            <a:avLst/>
+          </a:prstGeom>
+          <a:noFill/>
+          <a:ln/>
+        </p:spPr>
+        <p:txBody>
+          <a:bodyPr wrap="square" lIns="0" tIns="0" rIns="0" bIns="0" rtlCol="0" anchor="t">
+            <a:normAutofit/>
+          </a:bodyPr>
+          <a:lstStyle/>
+          <a:p>
+            <a:pPr indent="0" marL="0">
+              <a:buNone/>
+            </a:pPr>
+            <a:r>
+              <a:rPr lang="en-US" sz="900" dirty="0">
+                <a:solidFill>
+                  <a:srgbClr val="6C757D"/>
+                </a:solidFill>
+                <a:latin typeface="Open Sans" pitchFamily="34" charset="0"/>
+                <a:ea typeface="Open Sans" pitchFamily="34" charset="-122"/>
+                <a:cs typeface="Open Sans" pitchFamily="34" charset="-120"/>
+              </a:rPr>
+              <a:t>Sales, cost and gross profit / sqft; area coverage</a:t>
+            </a:r>
+            <a:endParaRPr lang="en-US" sz="900" dirty="0"/>
+          </a:p>
+        </p:txBody>
+      </p:sp>
+      <p:sp>
+        <p:nvSpPr>
+          <p:cNvPr id="28" name="Text 26"/>
+          <p:cNvSpPr/>
+          <p:nvPr/>
+        </p:nvSpPr>
+        <p:spPr>
+          <a:xfrm>
+            <a:off x="6519672" y="4005072"/>
+            <a:ext cx="2011680" cy="256032"/>
+          </a:xfrm>
+          <a:prstGeom prst="rect">
+            <a:avLst/>
+          </a:prstGeom>
+          <a:noFill/>
+          <a:ln/>
+        </p:spPr>
+        <p:txBody>
+          <a:bodyPr wrap="square" lIns="0" tIns="0" rIns="0" bIns="0" rtlCol="0" anchor="ctr">
+            <a:normAutofit/>
+          </a:bodyPr>
+          <a:lstStyle/>
+          <a:p>
+            <a:pPr indent="0" marL="0">
+              <a:buNone/>
+            </a:pPr>
+            <a:r>
+              <a:rPr lang="en-US" sz="1000" b="1" dirty="0">
+                <a:solidFill>
+                  <a:srgbClr val="6E9117"/>
+                </a:solidFill>
+                <a:latin typeface="Open Sans" pitchFamily="34" charset="0"/>
+                <a:ea typeface="Open Sans" pitchFamily="34" charset="-122"/>
+                <a:cs typeface="Open Sans" pitchFamily="34" charset="-120"/>
+              </a:rPr>
+              <a:t>Sales Ops</a:t>
+            </a:r>
+            <a:endParaRPr lang="en-US" sz="1000" dirty="0"/>
+          </a:p>
+        </p:txBody>
+      </p:sp>
+      <p:sp>
+        <p:nvSpPr>
+          <p:cNvPr id="29" name="Text 27"/>
+          <p:cNvSpPr/>
+          <p:nvPr/>
+        </p:nvSpPr>
+        <p:spPr>
+          <a:xfrm>
+            <a:off x="8577072" y="4005072"/>
+            <a:ext cx="3429000" cy="411480"/>
+          </a:xfrm>
+          <a:prstGeom prst="rect">
+            <a:avLst/>
+          </a:prstGeom>
+          <a:noFill/>
+          <a:ln/>
+        </p:spPr>
+        <p:txBody>
+          <a:bodyPr wrap="square" lIns="0" tIns="0" rIns="0" bIns="0" rtlCol="0" anchor="t">
+            <a:normAutofit/>
+          </a:bodyPr>
+          <a:lstStyle/>
+          <a:p>
+            <a:pPr indent="0" marL="0">
+              <a:buNone/>
+            </a:pPr>
+            <a:r>
+              <a:rPr lang="en-US" sz="900" dirty="0">
+                <a:solidFill>
+                  <a:srgbClr val="6C757D"/>
+                </a:solidFill>
+                <a:latin typeface="Open Sans" pitchFamily="34" charset="0"/>
+                <a:ea typeface="Open Sans" pitchFamily="34" charset="-122"/>
+                <a:cs typeface="Open Sans" pitchFamily="34" charset="-120"/>
+              </a:rPr>
+              <a:t>Sales / event; return-line rate; ID-version monitoring</a:t>
+            </a:r>
+            <a:endParaRPr lang="en-US" sz="900" dirty="0"/>
+          </a:p>
+        </p:txBody>
+      </p:sp>
+      <p:sp>
+        <p:nvSpPr>
+          <p:cNvPr id="30" name="Text 28"/>
+          <p:cNvSpPr/>
+          <p:nvPr/>
+        </p:nvSpPr>
+        <p:spPr>
+          <a:xfrm>
+            <a:off x="896112" y="5742432"/>
+            <a:ext cx="10469880" cy="384048"/>
+          </a:xfrm>
+          <a:prstGeom prst="rect">
+            <a:avLst/>
+          </a:prstGeom>
+          <a:noFill/>
+          <a:ln/>
+        </p:spPr>
+        <p:txBody>
+          <a:bodyPr wrap="square" lIns="0" tIns="0" rIns="0" bIns="0" rtlCol="0" anchor="ctr">
+            <a:normAutofit/>
+          </a:bodyPr>
+          <a:lstStyle/>
+          <a:p>
+            <a:pPr indent="0" marL="0">
+              <a:buNone/>
+            </a:pPr>
+            <a:r>
+              <a:rPr lang="en-US" sz="900" b="1" dirty="0">
+                <a:solidFill>
+                  <a:srgbClr val="B5473A"/>
+                </a:solidFill>
+                <a:latin typeface="Open Sans" pitchFamily="34" charset="0"/>
+                <a:ea typeface="Open Sans" pitchFamily="34" charset="-122"/>
+                <a:cs typeface="Open Sans" pitchFamily="34" charset="-120"/>
+              </a:rPr>
+              <a:t>Quantity, price and cost grains still need an upstream contract. Pack-equivalent counts are provisional; gross profit is not net profit.</a:t>
+            </a:r>
+            <a:endParaRPr lang="en-US" sz="900" dirty="0"/>
+          </a:p>
+        </p:txBody>
+      </p:sp>
+      <p:sp>
+        <p:nvSpPr>
+          <p:cNvPr id="25" name="Slide Number Placeholder 0"/>
+          <p:cNvSpPr>
+            <a:spLocks noGrp="1"/>
+          </p:cNvSpPr>
+          <p:nvPr>
+            <p:ph type="sldNum" sz="quarter" idx="4294967295"/>
+          </p:nvPr>
+        </p:nvSpPr>
+        <p:spPr>
+          <a:xfrm>
+            <a:off x="11201400" y="6473952"/>
+            <a:ext cx="800000" cy="300000"/>
+          </a:xfrm>
+          <a:prstGeom prst="rect">
+            <a:avLst/>
+          </a:prstGeom>
+          <a:extLst>
+            <a:ext uri="{C572A759-6A51-4108-AA02-DFA0A04FC94B}">
+              <ma14:wrappingTextBoxFlag xmlns:ma14="http://schemas.microsoft.com/office/mac/drawingml/2011/main" val="0"/>
+            </a:ext>
+          </a:extLst>
+        </p:spPr>
+        <p:txBody>
+          <a:bodyPr/>
+          <a:lstStyle>
+            <a:lvl1pPr>
+              <a:defRPr sz="900">
+                <a:solidFill>
+                  <a:srgbClr val="6C757D"/>
+                </a:solidFill>
+                <a:latin typeface="Open Sans"/>
+                <a:ea typeface="Open Sans"/>
+                <a:cs typeface="Open Sans"/>
+              </a:defRPr>
+            </a:lvl1pPr>
+          </a:lstStyle>
+          <a:p>
+            <a:pPr algn="l"/>
+            <a:fld id="{F7021451-1387-4CA6-816F-3879F97B5CBC}" type="slidenum">
+              <a:rPr b="0" lang="en-US"/>
+              <a:t>12</a:t>
             </a:fld>
             <a:endParaRPr lang="en-US"/>
           </a:p>

</xml_diff>

<commit_message>
Stakeholder headline tiles, column glossary, older duplicate versions to triage
- Headline tiles follow the four stakeholder notes: Finance (standard cost margin), AP/Ops (landed cost margin), Sales ops (latest ingested_at wins), FP&A vs Store Finance (store opex read as annual, monthly rejected with evidence).
- First tab opens with a glossary of every column in the file and how the model uses it; prose trimmed.
- mart_data_quality_triage now holds only the older version of each colliding transaction ID (9,815 rows); the newest ingested_at version is in the fact. New test enforces one triage row per collision.
- SPEC/METRIC_DICTIONARY record the annual-opex decision; deck notes and labels updated.

Co-authored-by: Copilot <223556219+Copilot@users.noreply.github.com>
</commit_message>
<xml_diff>
--- a/presentation/retail_ceo_debrief.pptx
+++ b/presentation/retail_ceo_debrief.pptx
@@ -601,7 +601,7 @@
           <a:p>
             <a:r>
               <a:rPr lang="en-US" dirty="0"/>
-              <a:t>The CSV has 509,480 rows and 499,665 distinct transaction IDs, leaving 9,815 excess versions. The version audit keeps all 509,480 rows; one latest version per ID feeds the 499,665-row fact and 9,815 older versions are explicitly marked for triage. The duplicate issue category contains both versions for each collided ID (19,630 rows). Other issue categories overlap, so their counts must not be summed as distinct dropped records.</a:t>
+              <a:t>The CSV has 509,480 rows and 499,665 distinct transaction IDs, leaving 9,815 excess versions. The version audit keeps all 509,480 rows; one latest version per ID feeds the 499,665-row fact and 9,815 older versions are explicitly marked for triage. The duplicate issue category holds the 9,815 older versions only; the selected versions are in the fact. Other issue categories overlap, so their counts must not be summed as distinct dropped records.</a:t>
             </a:r>
             <a:endParaRPr lang="en-US" dirty="0"/>
           </a:p>
@@ -1041,7 +1041,7 @@
           <a:p>
             <a:r>
               <a:rPr lang="en-US" dirty="0"/>
-              <a:t>The 9,815 colliding IDs appear as 19,630 row-level exception records because both source versions are visible. Missing product and store keys also include 99901 placeholder values, so counts exceed the raw null counts. The data contract asks upstream for a real line key and explicit unknown semantics.</a:t>
+              <a:t>Each of the 9,815 colliding IDs contributes exactly one triage row: the older version. The latest ingested_at version is in the fact, per Sales Ops. Missing product and store keys also include 99901 placeholder values, so counts exceed the raw null counts. The data contract asks upstream for a real line key and explicit unknown semantics.</a:t>
             </a:r>
             <a:endParaRPr lang="en-US" dirty="0"/>
           </a:p>
@@ -3639,7 +3639,7 @@
                 <a:ea typeface="Open Sans" pitchFamily="34" charset="-122"/>
                 <a:cs typeface="Open Sans" pitchFamily="34" charset="-120"/>
               </a:rPr>
-              <a:t>19,630 duplicate-version rows</a:t>
+              <a:t>9,815 older versions moved to triage</a:t>
             </a:r>
             <a:endParaRPr lang="en-US" sz="1500" dirty="0"/>
           </a:p>
@@ -3680,7 +3680,7 @@
                 <a:ea typeface="Open Sans" pitchFamily="34" charset="-122"/>
                 <a:cs typeface="Open Sans" pitchFamily="34" charset="-120"/>
               </a:rPr>
-              <a:t>9,815 IDs x 2 versions; both versions are logged in triage.</a:t>
+              <a:t>9,815 IDs x 2 versions; latest ingested_at kept, older sent to triage.</a:t>
             </a:r>
             <a:endParaRPr lang="en-US" sz="900" dirty="0"/>
           </a:p>
@@ -3832,7 +3832,7 @@
                 <a:ea typeface="Open Sans" pitchFamily="34" charset="-122"/>
                 <a:cs typeface="Open Sans" pitchFamily="34" charset="-120"/>
               </a:rPr>
-              <a:t>28,668 total issue rows / 28,563 distinct source rows flagged (categories overlap).</a:t>
+              <a:t>18,853 total issue rows / 18,748 distinct source rows flagged (categories overlap).</a:t>
             </a:r>
             <a:endParaRPr lang="en-US" sz="1200" dirty="0"/>
           </a:p>

</xml_diff>